<commit_message>
Week 5 pre-shoot sweep (Tue 9/29): lines re-read, injuries into notes, deck rebuilt
- make_episode_deck.py: Pitt at VT market -3.5 (from -4.5), PSU at NW -2.5 (from -3); honesty text updated
- notes: availability bullets per game, superdog picks re-ranked on Tuesday lines, rank mentions refreshed
- hot_seat_heisman.py: Sayin +3000 added to MARKET
- boards_week5.json / card_data_week5.json republished on tonight's ratings; deck 21 slides, lint clean

Co-Authored-By: Claude Fable 5.1 <noreply@anthropic.com>
</commit_message>
<xml_diff>
--- a/decks/2026_Week5_Episode6.pptx
+++ b/decks/2026_Week5_Episode6.pptx
@@ -14321,7 +14321,7 @@
                 </a:solidFill>
                 <a:latin typeface="Arial"/>
               </a:rPr>
-              <a:t>Tennessee –7.5</a:t>
+              <a:t>Tennessee –7</a:t>
             </a:r>
           </a:p>
         </p:txBody>
@@ -16502,7 +16502,7 @@
                 </a:solidFill>
                 <a:latin typeface="Arial"/>
               </a:rPr>
-              <a:t>Ohio State –13.5</a:t>
+              <a:t>Ohio State –14</a:t>
             </a:r>
           </a:p>
         </p:txBody>
@@ -23398,7 +23398,7 @@
                 </a:solidFill>
                 <a:latin typeface="Arial"/>
               </a:rPr>
-              <a:t>Pittsburgh 27 – Virginia Tech 26</a:t>
+              <a:t>Pittsburgh 28 – Virginia Tech 27</a:t>
             </a:r>
           </a:p>
         </p:txBody>
@@ -23433,7 +23433,7 @@
                 </a:solidFill>
                 <a:latin typeface="Arial"/>
               </a:rPr>
-              <a:t>machine Pittsburgh –0.5  ·  market Virginia Tech –4  ·  machine 4.5 higher on Pittsburgh</a:t>
+              <a:t>machine Pittsburgh –0.5  ·  market Virginia Tech –3.5  ·  machine 4 higher on Pittsburgh</a:t>
             </a:r>
           </a:p>
         </p:txBody>
@@ -24288,7 +24288,7 @@
                 </a:solidFill>
                 <a:latin typeface="Arial"/>
               </a:rPr>
-              <a:t>machine Tennessee –7  ·  market Tennessee –7.5  ·  machine agrees</a:t>
+              <a:t>machine Tennessee –7  ·  market Tennessee –7  ·  machine agrees</a:t>
             </a:r>
           </a:p>
         </p:txBody>
@@ -24573,7 +24573,7 @@
                 </a:solidFill>
                 <a:latin typeface="Arial"/>
               </a:rPr>
-              <a:t>machine Ohio State –14  ·  market Ohio State –13.5  ·  machine agrees</a:t>
+              <a:t>machine Ohio State –14  ·  market Ohio State –14  ·  machine agrees</a:t>
             </a:r>
           </a:p>
         </p:txBody>
@@ -24757,7 +24757,7 @@
                 </a:solidFill>
                 <a:latin typeface="Arial"/>
               </a:rPr>
-              <a:t>Clemson +17.5 vs #4 Miami</a:t>
+              <a:t>Boston College +21 at #21 SMU</a:t>
             </a:r>
           </a:p>
         </p:txBody>
@@ -24792,7 +24792,7 @@
                 </a:solidFill>
                 <a:latin typeface="Arial"/>
               </a:rPr>
-              <a:t>Superdogs: 5 for a cover · 5 + the spread for a win · 1 for a push · research, not picks · market = DraftKings, Sep 27</a:t>
+              <a:t>Superdogs: 5 for a cover · 5 + the spread for a win · 1 for a push · research, not picks · market = DraftKings, Sep 29</a:t>
             </a:r>
           </a:p>
         </p:txBody>
@@ -30916,7 +30916,7 @@
                 </a:solidFill>
                 <a:latin typeface="Arial"/>
               </a:rPr>
-              <a:t>Virginia Tech –4</a:t>
+              <a:t>Virginia Tech –3.5</a:t>
             </a:r>
           </a:p>
         </p:txBody>
@@ -30986,7 +30986,7 @@
                 </a:solidFill>
                 <a:latin typeface="Arial"/>
               </a:rPr>
-              <a:t>Pittsburgh 27 – Virginia Tech 26</a:t>
+              <a:t>Pittsburgh 28 – Virginia Tech 27</a:t>
             </a:r>
           </a:p>
         </p:txBody>

</xml_diff>

<commit_message>
deck: per game, the two team slides come first and the number/prediction slide last (Lucas 9/29)
Co-Authored-By: Claude Fable 5.1 <noreply@anthropic.com>
</commit_message>
<xml_diff>
--- a/decks/2026_Week5_Episode6.pptx
+++ b/decks/2026_Week5_Episode6.pptx
@@ -10,21 +10,21 @@
     <p:sldId id="258" r:id="rId9"/>
     <p:sldId id="259" r:id="rId10"/>
     <p:sldId id="260" r:id="rId11"/>
-    <p:sldId id="261" r:id="rId12"/>
     <p:sldId id="262" r:id="rId13"/>
     <p:sldId id="263" r:id="rId14"/>
-    <p:sldId id="264" r:id="rId15"/>
+    <p:sldId id="261" r:id="rId12"/>
     <p:sldId id="265" r:id="rId16"/>
     <p:sldId id="266" r:id="rId17"/>
-    <p:sldId id="267" r:id="rId18"/>
+    <p:sldId id="264" r:id="rId15"/>
     <p:sldId id="268" r:id="rId19"/>
     <p:sldId id="269" r:id="rId20"/>
-    <p:sldId id="270" r:id="rId21"/>
+    <p:sldId id="267" r:id="rId18"/>
     <p:sldId id="271" r:id="rId22"/>
     <p:sldId id="272" r:id="rId23"/>
-    <p:sldId id="273" r:id="rId24"/>
+    <p:sldId id="270" r:id="rId21"/>
     <p:sldId id="274" r:id="rId25"/>
     <p:sldId id="275" r:id="rId26"/>
+    <p:sldId id="273" r:id="rId24"/>
     <p:sldId id="276" r:id="rId27"/>
   </p:sldIdLst>
   <p:sldSz cx="12191695" cy="6858000" type="screen4x3"/>

</xml_diff>

<commit_message>
Heisman: all-positions board (points added per game x team factor) on the slide; QB efficiency index kept; slide subtitles computed from box scores
Co-Authored-By: Claude Fable 5.1 <noreply@anthropic.com>
</commit_message>
<xml_diff>
--- a/decks/2026_Week5_Episode6.pptx
+++ b/decks/2026_Week5_Episode6.pptx
@@ -24923,7 +24923,7 @@
                 </a:solidFill>
                 <a:latin typeface="Arial"/>
               </a:rPr>
-              <a:t>Team factor × QB efficiency (PPA per play)</a:t>
+              <a:t>Any position · points added per game (PPA, shrunk toward 2025) × team factor</a:t>
             </a:r>
           </a:p>
         </p:txBody>
@@ -24958,7 +24958,7 @@
                 </a:solidFill>
                 <a:latin typeface="Arial"/>
               </a:rPr>
-              <a:t>QUARTERBACK · TEAM</a:t>
+              <a:t>PLAYER · POS · TEAM</a:t>
             </a:r>
           </a:p>
         </p:txBody>
@@ -25063,7 +25063,7 @@
                 </a:solidFill>
                 <a:latin typeface="Arial"/>
               </a:rPr>
-              <a:t>BLEND</a:t>
+              <a:t>PTS / GAME</a:t>
             </a:r>
           </a:p>
         </p:txBody>
@@ -25263,7 +25263,7 @@
       </p:sp>
       <p:pic>
         <p:nvPicPr>
-          <p:cNvPr id="14" name="Picture 13" descr="miami.png"/>
+          <p:cNvPr id="14" name="Picture 13" descr="ohiostate.png"/>
           <p:cNvPicPr>
             <a:picLocks noChangeAspect="1"/>
           </p:cNvPicPr>
@@ -25315,7 +25315,7 @@
                 </a:solidFill>
                 <a:latin typeface="Arial"/>
               </a:rPr>
-              <a:t>71-of-79, 873 yards, 11 TD, 0 INT through three</a:t>
+              <a:t>83-of-115, 1,206 yards, 10 TD, 1 INT through four</a:t>
             </a:r>
           </a:p>
         </p:txBody>
@@ -25350,7 +25350,7 @@
                 </a:solidFill>
                 <a:latin typeface="Arial"/>
               </a:rPr>
-              <a:t>Darian Mensah · Miami</a:t>
+              <a:t>Julian Sayin · QB · Ohio State</a:t>
             </a:r>
           </a:p>
         </p:txBody>
@@ -25385,7 +25385,7 @@
                 </a:solidFill>
                 <a:latin typeface="Arial"/>
               </a:rPr>
-              <a:t>0.861 (112)</a:t>
+              <a:t>0.63 (131)</a:t>
             </a:r>
           </a:p>
         </p:txBody>
@@ -25420,7 +25420,7 @@
                 </a:solidFill>
                 <a:latin typeface="Arial"/>
               </a:rPr>
-              <a:t>0.371</a:t>
+              <a:t>0.55</a:t>
             </a:r>
           </a:p>
         </p:txBody>
@@ -25455,7 +25455,7 @@
                 </a:solidFill>
                 <a:latin typeface="Arial"/>
               </a:rPr>
-              <a:t>0.580</a:t>
+              <a:t>19.1</a:t>
             </a:r>
           </a:p>
         </p:txBody>
@@ -25490,7 +25490,7 @@
                 </a:solidFill>
                 <a:latin typeface="Arial"/>
               </a:rPr>
-              <a:t>77%</a:t>
+              <a:t>62%</a:t>
             </a:r>
           </a:p>
         </p:txBody>
@@ -25525,7 +25525,7 @@
                 </a:solidFill>
                 <a:latin typeface="Arial"/>
               </a:rPr>
-              <a:t>51.4</a:t>
+              <a:t>15.5</a:t>
             </a:r>
           </a:p>
         </p:txBody>
@@ -25611,7 +25611,7 @@
       </p:sp>
       <p:pic>
         <p:nvPicPr>
-          <p:cNvPr id="24" name="Picture 23" descr="notredame.png"/>
+          <p:cNvPr id="24" name="Picture 23" descr="miami.png"/>
           <p:cNvPicPr>
             <a:picLocks noChangeAspect="1"/>
           </p:cNvPicPr>
@@ -25663,7 +25663,7 @@
                 </a:solidFill>
                 <a:latin typeface="Arial"/>
               </a:rPr>
-              <a:t>53-of-73, 726 yards, 6 TD, 0 INT through three</a:t>
+              <a:t>94-of-106, 1,211 yards, 14 TD, 0 INT through four</a:t>
             </a:r>
           </a:p>
         </p:txBody>
@@ -25698,7 +25698,7 @@
                 </a:solidFill>
                 <a:latin typeface="Arial"/>
               </a:rPr>
-              <a:t>C.J. Carr · Notre Dame</a:t>
+              <a:t>Darian Mensah · QB · Miami</a:t>
             </a:r>
           </a:p>
         </p:txBody>
@@ -25733,7 +25733,7 @@
                 </a:solidFill>
                 <a:latin typeface="Arial"/>
               </a:rPr>
-              <a:t>0.595 (103)</a:t>
+              <a:t>0.86 (112)</a:t>
             </a:r>
           </a:p>
         </p:txBody>
@@ -25768,7 +25768,7 @@
                 </a:solidFill>
                 <a:latin typeface="Arial"/>
               </a:rPr>
-              <a:t>0.433</a:t>
+              <a:t>0.37</a:t>
             </a:r>
           </a:p>
         </p:txBody>
@@ -25803,7 +25803,7 @@
                 </a:solidFill>
                 <a:latin typeface="Arial"/>
               </a:rPr>
-              <a:t>0.499</a:t>
+              <a:t>16.2</a:t>
             </a:r>
           </a:p>
         </p:txBody>
@@ -25838,7 +25838,7 @@
                 </a:solidFill>
                 <a:latin typeface="Arial"/>
               </a:rPr>
-              <a:t>91%</a:t>
+              <a:t>77%</a:t>
             </a:r>
           </a:p>
         </p:txBody>
@@ -25873,7 +25873,7 @@
                 </a:solidFill>
                 <a:latin typeface="Arial"/>
               </a:rPr>
-              <a:t>47.6</a:t>
+              <a:t>14.4</a:t>
             </a:r>
           </a:p>
         </p:txBody>
@@ -26003,7 +26003,7 @@
       </p:sp>
       <p:pic>
         <p:nvPicPr>
-          <p:cNvPr id="35" name="Picture 34" descr="ohiostate.png"/>
+          <p:cNvPr id="35" name="Picture 34" descr="notredame.png"/>
           <p:cNvPicPr>
             <a:picLocks noChangeAspect="1"/>
           </p:cNvPicPr>
@@ -26055,7 +26055,7 @@
                 </a:solidFill>
                 <a:latin typeface="Arial"/>
               </a:rPr>
-              <a:t>56-of-79, 839 yards, 6 TD, 1 INT through three</a:t>
+              <a:t>67-of-95, 963 yards, 9 TD, 1 INT through four</a:t>
             </a:r>
           </a:p>
         </p:txBody>
@@ -26090,7 +26090,7 @@
                 </a:solidFill>
                 <a:latin typeface="Arial"/>
               </a:rPr>
-              <a:t>Julian Sayin · Ohio State</a:t>
+              <a:t>C.J. Carr · QB · Notre Dame</a:t>
             </a:r>
           </a:p>
         </p:txBody>
@@ -26125,7 +26125,7 @@
                 </a:solidFill>
                 <a:latin typeface="Arial"/>
               </a:rPr>
-              <a:t>0.628 (131)</a:t>
+              <a:t>0.59 (103)</a:t>
             </a:r>
           </a:p>
         </p:txBody>
@@ -26160,7 +26160,7 @@
                 </a:solidFill>
                 <a:latin typeface="Arial"/>
               </a:rPr>
-              <a:t>0.545</a:t>
+              <a:t>0.43</a:t>
             </a:r>
           </a:p>
         </p:txBody>
@@ -26195,7 +26195,7 @@
                 </a:solidFill>
                 <a:latin typeface="Arial"/>
               </a:rPr>
-              <a:t>0.584</a:t>
+              <a:t>12.8</a:t>
             </a:r>
           </a:p>
         </p:txBody>
@@ -26230,7 +26230,7 @@
                 </a:solidFill>
                 <a:latin typeface="Arial"/>
               </a:rPr>
-              <a:t>62%</a:t>
+              <a:t>91%</a:t>
             </a:r>
           </a:p>
         </p:txBody>
@@ -26265,7 +26265,7 @@
                 </a:solidFill>
                 <a:latin typeface="Arial"/>
               </a:rPr>
-              <a:t>47.3</a:t>
+              <a:t>12.3</a:t>
             </a:r>
           </a:p>
         </p:txBody>
@@ -26351,7 +26351,7 @@
       </p:sp>
       <p:pic>
         <p:nvPicPr>
-          <p:cNvPr id="45" name="Picture 44" descr="indiana.png"/>
+          <p:cNvPr id="45" name="Picture 44" descr="utah.png"/>
           <p:cNvPicPr>
             <a:picLocks noChangeAspect="1"/>
           </p:cNvPicPr>
@@ -26403,7 +26403,7 @@
                 </a:solidFill>
                 <a:latin typeface="Arial"/>
               </a:rPr>
-              <a:t>37-of-51, 649 yards, 10 TD, 0 INT through three</a:t>
+              <a:t>71-of-101, 896 yards, 9 TD, 1 INT · 136 rushing, 2 TD through four</a:t>
             </a:r>
           </a:p>
         </p:txBody>
@@ -26438,7 +26438,7 @@
                 </a:solidFill>
                 <a:latin typeface="Arial"/>
               </a:rPr>
-              <a:t>Josh Hoover · Indiana</a:t>
+              <a:t>Devon Dampier · QB · Utah</a:t>
             </a:r>
           </a:p>
         </p:txBody>
@@ -26473,7 +26473,7 @@
                 </a:solidFill>
                 <a:latin typeface="Arial"/>
               </a:rPr>
-              <a:t>0.756 (90)</a:t>
+              <a:t>0.43 (133)</a:t>
             </a:r>
           </a:p>
         </p:txBody>
@@ -26508,7 +26508,7 @@
                 </a:solidFill>
                 <a:latin typeface="Arial"/>
               </a:rPr>
-              <a:t>0.353</a:t>
+              <a:t>0.41</a:t>
             </a:r>
           </a:p>
         </p:txBody>
@@ -26543,7 +26543,7 @@
                 </a:solidFill>
                 <a:latin typeface="Arial"/>
               </a:rPr>
-              <a:t>0.504</a:t>
+              <a:t>14.1</a:t>
             </a:r>
           </a:p>
         </p:txBody>
@@ -26578,7 +26578,7 @@
                 </a:solidFill>
                 <a:latin typeface="Arial"/>
               </a:rPr>
-              <a:t>64%</a:t>
+              <a:t>58%</a:t>
             </a:r>
           </a:p>
         </p:txBody>
@@ -26613,7 +26613,7 @@
                 </a:solidFill>
                 <a:latin typeface="Arial"/>
               </a:rPr>
-              <a:t>41.3</a:t>
+              <a:t>11.1</a:t>
             </a:r>
           </a:p>
         </p:txBody>
@@ -26743,7 +26743,7 @@
       </p:sp>
       <p:pic>
         <p:nvPicPr>
-          <p:cNvPr id="56" name="Picture 55" descr="utah.png"/>
+          <p:cNvPr id="56" name="Picture 55" descr="alabama.png"/>
           <p:cNvPicPr>
             <a:picLocks noChangeAspect="1"/>
           </p:cNvPicPr>
@@ -26795,7 +26795,7 @@
                 </a:solidFill>
                 <a:latin typeface="Arial"/>
               </a:rPr>
-              <a:t>53-of-74, 690 yards, 7 TD, 1 INT · 115 rushing, 2 TD</a:t>
+              <a:t>78-of-110, 1,129 yards, 8 TD, 2 INT · 168 rushing, 3 TD through four</a:t>
             </a:r>
           </a:p>
         </p:txBody>
@@ -26830,7 +26830,7 @@
                 </a:solidFill>
                 <a:latin typeface="Arial"/>
               </a:rPr>
-              <a:t>Devon Dampier · Utah</a:t>
+              <a:t>Keelon Russell · QB · Alabama</a:t>
             </a:r>
           </a:p>
         </p:txBody>
@@ -26865,7 +26865,7 @@
                 </a:solidFill>
                 <a:latin typeface="Arial"/>
               </a:rPr>
-              <a:t>0.435 (133)</a:t>
+              <a:t>0.58 (139)</a:t>
             </a:r>
           </a:p>
         </p:txBody>
@@ -26900,7 +26900,7 @@
                 </a:solidFill>
                 <a:latin typeface="Arial"/>
               </a:rPr>
-              <a:t>0.413</a:t>
+              <a:t>new</a:t>
             </a:r>
           </a:p>
         </p:txBody>
@@ -26935,7 +26935,7 @@
                 </a:solidFill>
                 <a:latin typeface="Arial"/>
               </a:rPr>
-              <a:t>0.423</a:t>
+              <a:t>15.9</a:t>
             </a:r>
           </a:p>
         </p:txBody>
@@ -26970,7 +26970,7 @@
                 </a:solidFill>
                 <a:latin typeface="Arial"/>
               </a:rPr>
-              <a:t>58%</a:t>
+              <a:t>40%</a:t>
             </a:r>
           </a:p>
         </p:txBody>
@@ -27005,7 +27005,7 @@
                 </a:solidFill>
                 <a:latin typeface="Arial"/>
               </a:rPr>
-              <a:t>33.4</a:t>
+              <a:t>11.1</a:t>
             </a:r>
           </a:p>
         </p:txBody>
@@ -27040,7 +27040,7 @@
                 </a:solidFill>
                 <a:latin typeface="Arial"/>
               </a:rPr>
-              <a:t>Next up: Keelon Russell 32.0 · Jayden Maiava 29.2 · Will Hammond 28.6 · Sam Leavitt 27.9</a:t>
+              <a:t>Next up: Sam Leavitt 11.0 · Jayden Maiava 10.0 · Jeremiah Smith 9.5 · Josh Hoover 9.3</a:t>
             </a:r>
           </a:p>
         </p:txBody>
@@ -27154,7 +27154,7 @@
                 </a:solidFill>
                 <a:latin typeface="Arial"/>
               </a:rPr>
-              <a:t>Darian Mensah, Miami · index 51.4</a:t>
+              <a:t>Julian Sayin, QB, Ohio State · index 15.5</a:t>
             </a:r>
           </a:p>
         </p:txBody>
@@ -27189,7 +27189,7 @@
                 </a:solidFill>
                 <a:latin typeface="Arial"/>
               </a:rPr>
-              <a:t>Non-QB watch: Jeremiah Smith (Ohio State) · Malachi Toney (Miami) · Ryan Wingo (Texas) · Trent Mosley (USC)</a:t>
+              <a:t>QB efficiency board (per play): Darian Mensah 51.4 · C.J. Carr 47.6 · Julian Sayin 47.3 · Josh Hoover 41.3 · Devon Dampier 33.4</a:t>
             </a:r>
           </a:p>
         </p:txBody>
@@ -27224,7 +27224,7 @@
                 </a:solidFill>
                 <a:latin typeface="Arial"/>
               </a:rPr>
-              <a:t>PPA = predicted points added per play · re-computes every rebuild</a:t>
+              <a:t>PPA = predicted points added (CFBD) · points a game = shrunk per-play PPA × plays ÷ games · team factor = 0.5 + half the team's odds of 10 wins</a:t>
             </a:r>
           </a:p>
         </p:txBody>

</xml_diff>

<commit_message>
Heisman slide framed as the machine's best-player board (best so far, not a prediction); predictor study queued in STATE
Co-Authored-By: Claude Fable 5.1 <noreply@anthropic.com>
</commit_message>
<xml_diff>
--- a/decks/2026_Week5_Episode6.pptx
+++ b/decks/2026_Week5_Episode6.pptx
@@ -24853,7 +24853,7 @@
                 </a:solidFill>
                 <a:latin typeface="Arial"/>
               </a:rPr>
-              <a:t>EPISODE 6 · WEEK 5 · OUR HEISMAN BOARD</a:t>
+              <a:t>EPISODE 6 · WEEK 5 · HEISMAN · BEST SO FAR, NOT A PREDICTION</a:t>
             </a:r>
           </a:p>
         </p:txBody>
@@ -24888,7 +24888,7 @@
                 </a:solidFill>
                 <a:latin typeface="Arial"/>
               </a:rPr>
-              <a:t>Our Heisman Favorite</a:t>
+              <a:t>The Machine's Best-Player Board</a:t>
             </a:r>
           </a:p>
         </p:txBody>
@@ -24923,7 +24923,7 @@
                 </a:solidFill>
                 <a:latin typeface="Arial"/>
               </a:rPr>
-              <a:t>Any position · points added per game (PPA, shrunk toward 2025) × team factor</a:t>
+              <a:t>Any position · points added per game (PPA, shrunk toward 2025) × team factor · who is playing best, not who wins in December</a:t>
             </a:r>
           </a:p>
         </p:txBody>
@@ -27119,7 +27119,7 @@
                 </a:solidFill>
                 <a:latin typeface="Arial"/>
               </a:rPr>
-              <a:t>★ OUR FAVORITE</a:t>
+              <a:t>★ BEST SO FAR</a:t>
             </a:r>
           </a:p>
         </p:txBody>

</xml_diff>

<commit_message>
Ep6 shoot day: Corey's Week 5 calls/boards/superdogs in (tracker, ledger, notes); closer with man calls; card date OCT 2-3; merge_flow handles short-name anchors + renamed Heisman slide; merged deck built
Co-Authored-By: Claude Fable 5.1 <noreply@anthropic.com>
</commit_message>
<xml_diff>
--- a/decks/2026_Week5_Episode6.pptx
+++ b/decks/2026_Week5_Episode6.pptx
@@ -23148,7 +23148,7 @@
                 </a:solidFill>
                 <a:latin typeface="Arial"/>
               </a:rPr>
-              <a:t>Our predictions</a:t>
+              <a:t>Our predictions — machine and man</a:t>
             </a:r>
           </a:p>
         </p:txBody>
@@ -23342,7 +23342,7 @@
         <p:spPr>
           <a:xfrm>
             <a:off x="2286000" y="1938528"/>
-            <a:ext cx="4937760" cy="365760"/>
+            <a:ext cx="2286000" cy="365760"/>
           </a:xfrm>
           <a:prstGeom prst="rect">
             <a:avLst/>
@@ -23357,7 +23357,7 @@
           <a:p>
             <a:pPr algn="l"/>
             <a:r>
-              <a:rPr sz="1600" b="1" i="0">
+              <a:rPr sz="1500" b="1" i="0">
                 <a:solidFill>
                   <a:srgbClr val="FFFFFF"/>
                 </a:solidFill>
@@ -23376,8 +23376,8 @@
         </p:nvSpPr>
         <p:spPr>
           <a:xfrm>
-            <a:off x="6400800" y="1837943"/>
-            <a:ext cx="4754880" cy="411480"/>
+            <a:off x="4480560" y="1856231"/>
+            <a:ext cx="3931920" cy="411480"/>
           </a:xfrm>
           <a:prstGeom prst="rect">
             <a:avLst/>
@@ -23392,13 +23392,13 @@
           <a:p>
             <a:pPr algn="r"/>
             <a:r>
-              <a:rPr sz="1900" b="1" i="0">
+              <a:rPr sz="1400" b="1" i="0">
                 <a:solidFill>
                   <a:srgbClr val="F47321"/>
                 </a:solidFill>
                 <a:latin typeface="Arial"/>
               </a:rPr>
-              <a:t>Pittsburgh 28 – Virginia Tech 27</a:t>
+              <a:t>Machine Pittsburgh 28 – Virginia Tech 27</a:t>
             </a:r>
           </a:p>
         </p:txBody>
@@ -23406,6 +23406,41 @@
       <p:sp>
         <p:nvSpPr>
           <p:cNvPr id="11" name="TextBox 10"/>
+          <p:cNvSpPr txBox="1"/>
+          <p:nvPr/>
+        </p:nvSpPr>
+        <p:spPr>
+          <a:xfrm>
+            <a:off x="8503920" y="1856231"/>
+            <a:ext cx="2651760" cy="411480"/>
+          </a:xfrm>
+          <a:prstGeom prst="rect">
+            <a:avLst/>
+          </a:prstGeom>
+          <a:noFill/>
+        </p:spPr>
+        <p:txBody>
+          <a:bodyPr wrap="square" lIns="0" rIns="0" tIns="0" bIns="0">
+            <a:spAutoFit/>
+          </a:bodyPr>
+          <a:lstStyle/>
+          <a:p>
+            <a:pPr algn="r"/>
+            <a:r>
+              <a:rPr sz="1400" b="1" i="0">
+                <a:solidFill>
+                  <a:srgbClr val="5CD68A"/>
+                </a:solidFill>
+                <a:latin typeface="Arial"/>
+              </a:rPr>
+              <a:t>Man Pittsburgh 28–27</a:t>
+            </a:r>
+          </a:p>
+        </p:txBody>
+      </p:sp>
+      <p:sp>
+        <p:nvSpPr>
+          <p:cNvPr id="12" name="TextBox 11"/>
           <p:cNvSpPr txBox="1"/>
           <p:nvPr/>
         </p:nvSpPr>
@@ -23440,7 +23475,7 @@
       </p:sp>
       <p:sp>
         <p:nvSpPr>
-          <p:cNvPr id="12" name="Rounded Rectangle 11"/>
+          <p:cNvPr id="13" name="Rounded Rectangle 12"/>
           <p:cNvSpPr/>
           <p:nvPr/>
         </p:nvSpPr>
@@ -23484,7 +23519,7 @@
       </p:sp>
       <p:sp>
         <p:nvSpPr>
-          <p:cNvPr id="13" name="Oval 12"/>
+          <p:cNvPr id="14" name="Oval 13"/>
           <p:cNvSpPr/>
           <p:nvPr/>
         </p:nvSpPr>
@@ -23528,7 +23563,7 @@
       </p:sp>
       <p:pic>
         <p:nvPicPr>
-          <p:cNvPr id="14" name="Picture 13" descr="pennstate.png"/>
+          <p:cNvPr id="15" name="Picture 14" descr="pennstate.png"/>
           <p:cNvPicPr>
             <a:picLocks noChangeAspect="1"/>
           </p:cNvPicPr>
@@ -23552,7 +23587,7 @@
       </p:pic>
       <p:sp>
         <p:nvSpPr>
-          <p:cNvPr id="15" name="Oval 14"/>
+          <p:cNvPr id="16" name="Oval 15"/>
           <p:cNvSpPr/>
           <p:nvPr/>
         </p:nvSpPr>
@@ -23596,7 +23631,7 @@
       </p:sp>
       <p:pic>
         <p:nvPicPr>
-          <p:cNvPr id="16" name="Picture 15" descr="northwestern.png"/>
+          <p:cNvPr id="17" name="Picture 16" descr="northwestern.png"/>
           <p:cNvPicPr>
             <a:picLocks noChangeAspect="1"/>
           </p:cNvPicPr>
@@ -23620,14 +23655,14 @@
       </p:pic>
       <p:sp>
         <p:nvSpPr>
-          <p:cNvPr id="17" name="TextBox 16"/>
+          <p:cNvPr id="18" name="TextBox 17"/>
           <p:cNvSpPr txBox="1"/>
           <p:nvPr/>
         </p:nvSpPr>
         <p:spPr>
           <a:xfrm>
             <a:off x="2286000" y="2670048"/>
-            <a:ext cx="4937760" cy="365760"/>
+            <a:ext cx="2286000" cy="365760"/>
           </a:xfrm>
           <a:prstGeom prst="rect">
             <a:avLst/>
@@ -23642,7 +23677,7 @@
           <a:p>
             <a:pPr algn="l"/>
             <a:r>
-              <a:rPr sz="1600" b="1" i="0">
+              <a:rPr sz="1500" b="1" i="0">
                 <a:solidFill>
                   <a:srgbClr val="FFFFFF"/>
                 </a:solidFill>
@@ -23655,14 +23690,14 @@
       </p:sp>
       <p:sp>
         <p:nvSpPr>
-          <p:cNvPr id="18" name="TextBox 17"/>
-          <p:cNvSpPr txBox="1"/>
-          <p:nvPr/>
-        </p:nvSpPr>
-        <p:spPr>
-          <a:xfrm>
-            <a:off x="6400800" y="2569464"/>
-            <a:ext cx="4754880" cy="411480"/>
+          <p:cNvPr id="19" name="TextBox 18"/>
+          <p:cNvSpPr txBox="1"/>
+          <p:nvPr/>
+        </p:nvSpPr>
+        <p:spPr>
+          <a:xfrm>
+            <a:off x="4480560" y="2587752"/>
+            <a:ext cx="3931920" cy="411480"/>
           </a:xfrm>
           <a:prstGeom prst="rect">
             <a:avLst/>
@@ -23677,20 +23712,55 @@
           <a:p>
             <a:pPr algn="r"/>
             <a:r>
-              <a:rPr sz="1900" b="1" i="0">
+              <a:rPr sz="1400" b="1" i="0">
                 <a:solidFill>
                   <a:srgbClr val="F47321"/>
                 </a:solidFill>
                 <a:latin typeface="Arial"/>
               </a:rPr>
-              <a:t>Penn State 24 – Northwestern 22</a:t>
-            </a:r>
-          </a:p>
-        </p:txBody>
-      </p:sp>
-      <p:sp>
-        <p:nvSpPr>
-          <p:cNvPr id="19" name="TextBox 18"/>
+              <a:t>Machine Penn State 24 – Northwestern 22</a:t>
+            </a:r>
+          </a:p>
+        </p:txBody>
+      </p:sp>
+      <p:sp>
+        <p:nvSpPr>
+          <p:cNvPr id="20" name="TextBox 19"/>
+          <p:cNvSpPr txBox="1"/>
+          <p:nvPr/>
+        </p:nvSpPr>
+        <p:spPr>
+          <a:xfrm>
+            <a:off x="8503920" y="2587752"/>
+            <a:ext cx="2651760" cy="411480"/>
+          </a:xfrm>
+          <a:prstGeom prst="rect">
+            <a:avLst/>
+          </a:prstGeom>
+          <a:noFill/>
+        </p:spPr>
+        <p:txBody>
+          <a:bodyPr wrap="square" lIns="0" rIns="0" tIns="0" bIns="0">
+            <a:spAutoFit/>
+          </a:bodyPr>
+          <a:lstStyle/>
+          <a:p>
+            <a:pPr algn="r"/>
+            <a:r>
+              <a:rPr sz="1400" b="1" i="0">
+                <a:solidFill>
+                  <a:srgbClr val="5CD68A"/>
+                </a:solidFill>
+                <a:latin typeface="Arial"/>
+              </a:rPr>
+              <a:t>Man Penn State 27–24</a:t>
+            </a:r>
+          </a:p>
+        </p:txBody>
+      </p:sp>
+      <p:sp>
+        <p:nvSpPr>
+          <p:cNvPr id="21" name="TextBox 20"/>
           <p:cNvSpPr txBox="1"/>
           <p:nvPr/>
         </p:nvSpPr>
@@ -23725,7 +23795,7 @@
       </p:sp>
       <p:sp>
         <p:nvSpPr>
-          <p:cNvPr id="20" name="Rounded Rectangle 19"/>
+          <p:cNvPr id="22" name="Rounded Rectangle 21"/>
           <p:cNvSpPr/>
           <p:nvPr/>
         </p:nvSpPr>
@@ -23769,7 +23839,7 @@
       </p:sp>
       <p:sp>
         <p:nvSpPr>
-          <p:cNvPr id="21" name="Oval 20"/>
+          <p:cNvPr id="23" name="Oval 22"/>
           <p:cNvSpPr/>
           <p:nvPr/>
         </p:nvSpPr>
@@ -23813,7 +23883,7 @@
       </p:sp>
       <p:pic>
         <p:nvPicPr>
-          <p:cNvPr id="22" name="Picture 21" descr="alabama.png"/>
+          <p:cNvPr id="24" name="Picture 23" descr="alabama.png"/>
           <p:cNvPicPr>
             <a:picLocks noChangeAspect="1"/>
           </p:cNvPicPr>
@@ -23837,7 +23907,7 @@
       </p:pic>
       <p:sp>
         <p:nvSpPr>
-          <p:cNvPr id="23" name="Oval 22"/>
+          <p:cNvPr id="25" name="Oval 24"/>
           <p:cNvSpPr/>
           <p:nvPr/>
         </p:nvSpPr>
@@ -23881,7 +23951,7 @@
       </p:sp>
       <p:pic>
         <p:nvPicPr>
-          <p:cNvPr id="24" name="Picture 23" descr="mississippistate.png"/>
+          <p:cNvPr id="26" name="Picture 25" descr="mississippistate.png"/>
           <p:cNvPicPr>
             <a:picLocks noChangeAspect="1"/>
           </p:cNvPicPr>
@@ -23905,14 +23975,14 @@
       </p:pic>
       <p:sp>
         <p:nvSpPr>
-          <p:cNvPr id="25" name="TextBox 24"/>
+          <p:cNvPr id="27" name="TextBox 26"/>
           <p:cNvSpPr txBox="1"/>
           <p:nvPr/>
         </p:nvSpPr>
         <p:spPr>
           <a:xfrm>
             <a:off x="2286000" y="3401568"/>
-            <a:ext cx="4937760" cy="365760"/>
+            <a:ext cx="2286000" cy="365760"/>
           </a:xfrm>
           <a:prstGeom prst="rect">
             <a:avLst/>
@@ -23927,7 +23997,7 @@
           <a:p>
             <a:pPr algn="l"/>
             <a:r>
-              <a:rPr sz="1600" b="1" i="0">
+              <a:rPr sz="1500" b="1" i="0">
                 <a:solidFill>
                   <a:srgbClr val="FFFFFF"/>
                 </a:solidFill>
@@ -23940,14 +24010,14 @@
       </p:sp>
       <p:sp>
         <p:nvSpPr>
-          <p:cNvPr id="26" name="TextBox 25"/>
-          <p:cNvSpPr txBox="1"/>
-          <p:nvPr/>
-        </p:nvSpPr>
-        <p:spPr>
-          <a:xfrm>
-            <a:off x="6400800" y="3300984"/>
-            <a:ext cx="4754880" cy="411480"/>
+          <p:cNvPr id="28" name="TextBox 27"/>
+          <p:cNvSpPr txBox="1"/>
+          <p:nvPr/>
+        </p:nvSpPr>
+        <p:spPr>
+          <a:xfrm>
+            <a:off x="4480560" y="3319272"/>
+            <a:ext cx="3931920" cy="411480"/>
           </a:xfrm>
           <a:prstGeom prst="rect">
             <a:avLst/>
@@ -23962,20 +24032,55 @@
           <a:p>
             <a:pPr algn="r"/>
             <a:r>
-              <a:rPr sz="1900" b="1" i="0">
+              <a:rPr sz="1400" b="1" i="0">
                 <a:solidFill>
                   <a:srgbClr val="F47321"/>
                 </a:solidFill>
                 <a:latin typeface="Arial"/>
               </a:rPr>
-              <a:t>Alabama 34 – Mississippi State 26</a:t>
-            </a:r>
-          </a:p>
-        </p:txBody>
-      </p:sp>
-      <p:sp>
-        <p:nvSpPr>
-          <p:cNvPr id="27" name="TextBox 26"/>
+              <a:t>Machine Alabama 34 – Mississippi State 26</a:t>
+            </a:r>
+          </a:p>
+        </p:txBody>
+      </p:sp>
+      <p:sp>
+        <p:nvSpPr>
+          <p:cNvPr id="29" name="TextBox 28"/>
+          <p:cNvSpPr txBox="1"/>
+          <p:nvPr/>
+        </p:nvSpPr>
+        <p:spPr>
+          <a:xfrm>
+            <a:off x="8503920" y="3319272"/>
+            <a:ext cx="2651760" cy="411480"/>
+          </a:xfrm>
+          <a:prstGeom prst="rect">
+            <a:avLst/>
+          </a:prstGeom>
+          <a:noFill/>
+        </p:spPr>
+        <p:txBody>
+          <a:bodyPr wrap="square" lIns="0" rIns="0" tIns="0" bIns="0">
+            <a:spAutoFit/>
+          </a:bodyPr>
+          <a:lstStyle/>
+          <a:p>
+            <a:pPr algn="r"/>
+            <a:r>
+              <a:rPr sz="1400" b="1" i="0">
+                <a:solidFill>
+                  <a:srgbClr val="5CD68A"/>
+                </a:solidFill>
+                <a:latin typeface="Arial"/>
+              </a:rPr>
+              <a:t>Man Alabama 38–28</a:t>
+            </a:r>
+          </a:p>
+        </p:txBody>
+      </p:sp>
+      <p:sp>
+        <p:nvSpPr>
+          <p:cNvPr id="30" name="TextBox 29"/>
           <p:cNvSpPr txBox="1"/>
           <p:nvPr/>
         </p:nvSpPr>
@@ -24010,7 +24115,7 @@
       </p:sp>
       <p:sp>
         <p:nvSpPr>
-          <p:cNvPr id="28" name="Rounded Rectangle 27"/>
+          <p:cNvPr id="31" name="Rounded Rectangle 30"/>
           <p:cNvSpPr/>
           <p:nvPr/>
         </p:nvSpPr>
@@ -24054,7 +24159,7 @@
       </p:sp>
       <p:sp>
         <p:nvSpPr>
-          <p:cNvPr id="29" name="Oval 28"/>
+          <p:cNvPr id="32" name="Oval 31"/>
           <p:cNvSpPr/>
           <p:nvPr/>
         </p:nvSpPr>
@@ -24098,7 +24203,7 @@
       </p:sp>
       <p:pic>
         <p:nvPicPr>
-          <p:cNvPr id="30" name="Picture 29" descr="auburn.png"/>
+          <p:cNvPr id="33" name="Picture 32" descr="auburn.png"/>
           <p:cNvPicPr>
             <a:picLocks noChangeAspect="1"/>
           </p:cNvPicPr>
@@ -24122,7 +24227,7 @@
       </p:pic>
       <p:sp>
         <p:nvSpPr>
-          <p:cNvPr id="31" name="Oval 30"/>
+          <p:cNvPr id="34" name="Oval 33"/>
           <p:cNvSpPr/>
           <p:nvPr/>
         </p:nvSpPr>
@@ -24166,7 +24271,7 @@
       </p:sp>
       <p:pic>
         <p:nvPicPr>
-          <p:cNvPr id="32" name="Picture 31" descr="tennessee.png"/>
+          <p:cNvPr id="35" name="Picture 34" descr="tennessee.png"/>
           <p:cNvPicPr>
             <a:picLocks noChangeAspect="1"/>
           </p:cNvPicPr>
@@ -24190,14 +24295,14 @@
       </p:pic>
       <p:sp>
         <p:nvSpPr>
-          <p:cNvPr id="33" name="TextBox 32"/>
+          <p:cNvPr id="36" name="TextBox 35"/>
           <p:cNvSpPr txBox="1"/>
           <p:nvPr/>
         </p:nvSpPr>
         <p:spPr>
           <a:xfrm>
             <a:off x="2286000" y="4133087"/>
-            <a:ext cx="4937760" cy="365760"/>
+            <a:ext cx="2286000" cy="365760"/>
           </a:xfrm>
           <a:prstGeom prst="rect">
             <a:avLst/>
@@ -24212,7 +24317,7 @@
           <a:p>
             <a:pPr algn="l"/>
             <a:r>
-              <a:rPr sz="1600" b="1" i="0">
+              <a:rPr sz="1500" b="1" i="0">
                 <a:solidFill>
                   <a:srgbClr val="FFFFFF"/>
                 </a:solidFill>
@@ -24225,14 +24330,14 @@
       </p:sp>
       <p:sp>
         <p:nvSpPr>
-          <p:cNvPr id="34" name="TextBox 33"/>
-          <p:cNvSpPr txBox="1"/>
-          <p:nvPr/>
-        </p:nvSpPr>
-        <p:spPr>
-          <a:xfrm>
-            <a:off x="6400800" y="4032503"/>
-            <a:ext cx="4754880" cy="411480"/>
+          <p:cNvPr id="37" name="TextBox 36"/>
+          <p:cNvSpPr txBox="1"/>
+          <p:nvPr/>
+        </p:nvSpPr>
+        <p:spPr>
+          <a:xfrm>
+            <a:off x="4480560" y="4050791"/>
+            <a:ext cx="3931920" cy="411480"/>
           </a:xfrm>
           <a:prstGeom prst="rect">
             <a:avLst/>
@@ -24247,20 +24352,55 @@
           <a:p>
             <a:pPr algn="r"/>
             <a:r>
-              <a:rPr sz="1900" b="1" i="0">
+              <a:rPr sz="1400" b="1" i="0">
                 <a:solidFill>
                   <a:srgbClr val="F47321"/>
                 </a:solidFill>
                 <a:latin typeface="Arial"/>
               </a:rPr>
-              <a:t>Tennessee 31 – Auburn 24</a:t>
-            </a:r>
-          </a:p>
-        </p:txBody>
-      </p:sp>
-      <p:sp>
-        <p:nvSpPr>
-          <p:cNvPr id="35" name="TextBox 34"/>
+              <a:t>Machine Tennessee 31 – Auburn 24</a:t>
+            </a:r>
+          </a:p>
+        </p:txBody>
+      </p:sp>
+      <p:sp>
+        <p:nvSpPr>
+          <p:cNvPr id="38" name="TextBox 37"/>
+          <p:cNvSpPr txBox="1"/>
+          <p:nvPr/>
+        </p:nvSpPr>
+        <p:spPr>
+          <a:xfrm>
+            <a:off x="8503920" y="4050791"/>
+            <a:ext cx="2651760" cy="411480"/>
+          </a:xfrm>
+          <a:prstGeom prst="rect">
+            <a:avLst/>
+          </a:prstGeom>
+          <a:noFill/>
+        </p:spPr>
+        <p:txBody>
+          <a:bodyPr wrap="square" lIns="0" rIns="0" tIns="0" bIns="0">
+            <a:spAutoFit/>
+          </a:bodyPr>
+          <a:lstStyle/>
+          <a:p>
+            <a:pPr algn="r"/>
+            <a:r>
+              <a:rPr sz="1400" b="1" i="0">
+                <a:solidFill>
+                  <a:srgbClr val="5CD68A"/>
+                </a:solidFill>
+                <a:latin typeface="Arial"/>
+              </a:rPr>
+              <a:t>Man Tennessee 31–21</a:t>
+            </a:r>
+          </a:p>
+        </p:txBody>
+      </p:sp>
+      <p:sp>
+        <p:nvSpPr>
+          <p:cNvPr id="39" name="TextBox 38"/>
           <p:cNvSpPr txBox="1"/>
           <p:nvPr/>
         </p:nvSpPr>
@@ -24295,7 +24435,7 @@
       </p:sp>
       <p:sp>
         <p:nvSpPr>
-          <p:cNvPr id="36" name="Rounded Rectangle 35"/>
+          <p:cNvPr id="40" name="Rounded Rectangle 39"/>
           <p:cNvSpPr/>
           <p:nvPr/>
         </p:nvSpPr>
@@ -24339,7 +24479,7 @@
       </p:sp>
       <p:sp>
         <p:nvSpPr>
-          <p:cNvPr id="37" name="Oval 36"/>
+          <p:cNvPr id="41" name="Oval 40"/>
           <p:cNvSpPr/>
           <p:nvPr/>
         </p:nvSpPr>
@@ -24383,7 +24523,7 @@
       </p:sp>
       <p:pic>
         <p:nvPicPr>
-          <p:cNvPr id="38" name="Picture 37" descr="ohiostate.png"/>
+          <p:cNvPr id="42" name="Picture 41" descr="ohiostate.png"/>
           <p:cNvPicPr>
             <a:picLocks noChangeAspect="1"/>
           </p:cNvPicPr>
@@ -24407,7 +24547,7 @@
       </p:pic>
       <p:sp>
         <p:nvSpPr>
-          <p:cNvPr id="39" name="Oval 38"/>
+          <p:cNvPr id="43" name="Oval 42"/>
           <p:cNvSpPr/>
           <p:nvPr/>
         </p:nvSpPr>
@@ -24451,7 +24591,7 @@
       </p:sp>
       <p:pic>
         <p:nvPicPr>
-          <p:cNvPr id="40" name="Picture 39" descr="iowa.png"/>
+          <p:cNvPr id="44" name="Picture 43" descr="iowa.png"/>
           <p:cNvPicPr>
             <a:picLocks noChangeAspect="1"/>
           </p:cNvPicPr>
@@ -24475,14 +24615,14 @@
       </p:pic>
       <p:sp>
         <p:nvSpPr>
-          <p:cNvPr id="41" name="TextBox 40"/>
+          <p:cNvPr id="45" name="TextBox 44"/>
           <p:cNvSpPr txBox="1"/>
           <p:nvPr/>
         </p:nvSpPr>
         <p:spPr>
           <a:xfrm>
             <a:off x="2286000" y="4864607"/>
-            <a:ext cx="4937760" cy="365760"/>
+            <a:ext cx="2286000" cy="365760"/>
           </a:xfrm>
           <a:prstGeom prst="rect">
             <a:avLst/>
@@ -24497,7 +24637,7 @@
           <a:p>
             <a:pPr algn="l"/>
             <a:r>
-              <a:rPr sz="1600" b="1" i="0">
+              <a:rPr sz="1500" b="1" i="0">
                 <a:solidFill>
                   <a:srgbClr val="FFFFFF"/>
                 </a:solidFill>
@@ -24510,14 +24650,14 @@
       </p:sp>
       <p:sp>
         <p:nvSpPr>
-          <p:cNvPr id="42" name="TextBox 41"/>
-          <p:cNvSpPr txBox="1"/>
-          <p:nvPr/>
-        </p:nvSpPr>
-        <p:spPr>
-          <a:xfrm>
-            <a:off x="6400800" y="4764023"/>
-            <a:ext cx="4754880" cy="411480"/>
+          <p:cNvPr id="46" name="TextBox 45"/>
+          <p:cNvSpPr txBox="1"/>
+          <p:nvPr/>
+        </p:nvSpPr>
+        <p:spPr>
+          <a:xfrm>
+            <a:off x="4480560" y="4782312"/>
+            <a:ext cx="3931920" cy="411480"/>
           </a:xfrm>
           <a:prstGeom prst="rect">
             <a:avLst/>
@@ -24532,20 +24672,55 @@
           <a:p>
             <a:pPr algn="r"/>
             <a:r>
-              <a:rPr sz="1900" b="1" i="0">
+              <a:rPr sz="1400" b="1" i="0">
                 <a:solidFill>
                   <a:srgbClr val="F47321"/>
                 </a:solidFill>
                 <a:latin typeface="Arial"/>
               </a:rPr>
-              <a:t>Ohio State 30 – Iowa 16</a:t>
-            </a:r>
-          </a:p>
-        </p:txBody>
-      </p:sp>
-      <p:sp>
-        <p:nvSpPr>
-          <p:cNvPr id="43" name="TextBox 42"/>
+              <a:t>Machine Ohio State 30 – Iowa 16</a:t>
+            </a:r>
+          </a:p>
+        </p:txBody>
+      </p:sp>
+      <p:sp>
+        <p:nvSpPr>
+          <p:cNvPr id="47" name="TextBox 46"/>
+          <p:cNvSpPr txBox="1"/>
+          <p:nvPr/>
+        </p:nvSpPr>
+        <p:spPr>
+          <a:xfrm>
+            <a:off x="8503920" y="4782312"/>
+            <a:ext cx="2651760" cy="411480"/>
+          </a:xfrm>
+          <a:prstGeom prst="rect">
+            <a:avLst/>
+          </a:prstGeom>
+          <a:noFill/>
+        </p:spPr>
+        <p:txBody>
+          <a:bodyPr wrap="square" lIns="0" rIns="0" tIns="0" bIns="0">
+            <a:spAutoFit/>
+          </a:bodyPr>
+          <a:lstStyle/>
+          <a:p>
+            <a:pPr algn="r"/>
+            <a:r>
+              <a:rPr sz="1400" b="1" i="0">
+                <a:solidFill>
+                  <a:srgbClr val="5CD68A"/>
+                </a:solidFill>
+                <a:latin typeface="Arial"/>
+              </a:rPr>
+              <a:t>Man Ohio State 31–20</a:t>
+            </a:r>
+          </a:p>
+        </p:txBody>
+      </p:sp>
+      <p:sp>
+        <p:nvSpPr>
+          <p:cNvPr id="48" name="TextBox 47"/>
           <p:cNvSpPr txBox="1"/>
           <p:nvPr/>
         </p:nvSpPr>
@@ -24580,7 +24755,7 @@
       </p:sp>
       <p:sp>
         <p:nvSpPr>
-          <p:cNvPr id="44" name="Rounded Rectangle 43"/>
+          <p:cNvPr id="49" name="Rounded Rectangle 48"/>
           <p:cNvSpPr/>
           <p:nvPr/>
         </p:nvSpPr>
@@ -24624,7 +24799,7 @@
       </p:sp>
       <p:sp>
         <p:nvSpPr>
-          <p:cNvPr id="45" name="TextBox 44"/>
+          <p:cNvPr id="50" name="TextBox 49"/>
           <p:cNvSpPr txBox="1"/>
           <p:nvPr/>
         </p:nvSpPr>
@@ -24659,7 +24834,7 @@
       </p:sp>
       <p:sp>
         <p:nvSpPr>
-          <p:cNvPr id="46" name="TextBox 45"/>
+          <p:cNvPr id="51" name="TextBox 50"/>
           <p:cNvSpPr txBox="1"/>
           <p:nvPr/>
         </p:nvSpPr>
@@ -24694,7 +24869,7 @@
       </p:sp>
       <p:sp>
         <p:nvSpPr>
-          <p:cNvPr id="47" name="TextBox 46"/>
+          <p:cNvPr id="52" name="TextBox 51"/>
           <p:cNvSpPr txBox="1"/>
           <p:nvPr/>
         </p:nvSpPr>
@@ -24729,7 +24904,7 @@
       </p:sp>
       <p:sp>
         <p:nvSpPr>
-          <p:cNvPr id="48" name="TextBox 47"/>
+          <p:cNvPr id="53" name="TextBox 52"/>
           <p:cNvSpPr txBox="1"/>
           <p:nvPr/>
         </p:nvSpPr>
@@ -24764,7 +24939,7 @@
       </p:sp>
       <p:sp>
         <p:nvSpPr>
-          <p:cNvPr id="49" name="TextBox 48"/>
+          <p:cNvPr id="54" name="TextBox 53"/>
           <p:cNvSpPr txBox="1"/>
           <p:nvPr/>
         </p:nvSpPr>
@@ -27285,7 +27460,7 @@
                 </a:solidFill>
                 <a:latin typeface="Arial"/>
               </a:rPr>
-              <a:t>EPISODE 6 · WEEK 5 · SEP 26, 2026</a:t>
+              <a:t>EPISODE 6 · WEEK 5 · OCT 2–3, 2026</a:t>
             </a:r>
           </a:p>
         </p:txBody>

</xml_diff>

<commit_message>
Ep6: games in Corey's deck order (OSU-Iowa 4th, Auburn-Tennessee closes); no merged deck files from now on (Lucas imports our slides himself)
Co-Authored-By: Claude Fable 5.1 <noreply@anthropic.com>
</commit_message>
<xml_diff>
--- a/decks/2026_Week5_Episode6.pptx
+++ b/decks/2026_Week5_Episode6.pptx
@@ -13763,7 +13763,7 @@
       <p:grpSpPr/>
       <p:pic>
         <p:nvPicPr>
-          <p:cNvPr id="2" name="Picture 1" descr="auburn.png"/>
+          <p:cNvPr id="2" name="Picture 1" descr="ohiostate.png"/>
           <p:cNvPicPr>
             <a:picLocks noChangeAspect="1"/>
           </p:cNvPicPr>
@@ -13822,7 +13822,7 @@
       </p:sp>
       <p:pic>
         <p:nvPicPr>
-          <p:cNvPr id="4" name="Picture 3" descr="tennessee.png"/>
+          <p:cNvPr id="4" name="Picture 3" descr="iowa.png"/>
           <p:cNvPicPr>
             <a:picLocks noChangeAspect="1"/>
           </p:cNvPicPr>
@@ -13874,7 +13874,7 @@
                 </a:solidFill>
                 <a:latin typeface="Arial"/>
               </a:rPr>
-              <a:t>Auburn at Tennessee</a:t>
+              <a:t>Ohio State at Iowa</a:t>
             </a:r>
           </a:p>
         </p:txBody>
@@ -13909,7 +13909,7 @@
                 </a:solidFill>
                 <a:latin typeface="Arial"/>
               </a:rPr>
-              <a:t>Sat Oct 3 · 3:30 ET · Knoxville · Auburn at No. 17</a:t>
+              <a:t>Sat Oct 3 · 3:30 ET · Iowa City · No. 5 at No. 14</a:t>
             </a:r>
           </a:p>
         </p:txBody>
@@ -14023,7 +14023,7 @@
                 </a:solidFill>
                 <a:latin typeface="Arial"/>
               </a:rPr>
-              <a:t>Tennessee out-played Texas and lost</a:t>
+              <a:t>Best passing game vs a run-stuffing defense</a:t>
             </a:r>
           </a:p>
         </p:txBody>
@@ -14102,7 +14102,7 @@
                 </a:solidFill>
                 <a:latin typeface="Arial"/>
               </a:rPr>
-              <a:t>67% — the machine and the market agree</a:t>
+              <a:t>81% — dead agreement with the market</a:t>
             </a:r>
           </a:p>
         </p:txBody>
@@ -14216,7 +14216,7 @@
                 </a:solidFill>
                 <a:latin typeface="Arial"/>
               </a:rPr>
-              <a:t>Tennessee –7</a:t>
+              <a:t>Ohio State –14</a:t>
             </a:r>
           </a:p>
         </p:txBody>
@@ -14251,7 +14251,7 @@
                 </a:solidFill>
                 <a:latin typeface="Arial"/>
               </a:rPr>
-              <a:t>Tennessee –205 · Auburn +205</a:t>
+              <a:t>Iowa +424 · Ohio State –424</a:t>
             </a:r>
           </a:p>
         </p:txBody>
@@ -14286,7 +14286,7 @@
                 </a:solidFill>
                 <a:latin typeface="Arial"/>
               </a:rPr>
-              <a:t>machine line · fair odds, no vig · raw margin Tennessee +6.8</a:t>
+              <a:t>machine line · fair odds, no vig · raw margin Ohio State +14.1</a:t>
             </a:r>
           </a:p>
         </p:txBody>
@@ -14321,7 +14321,7 @@
                 </a:solidFill>
                 <a:latin typeface="Arial"/>
               </a:rPr>
-              <a:t>Tennessee –7</a:t>
+              <a:t>Ohio State –14</a:t>
             </a:r>
           </a:p>
         </p:txBody>
@@ -14391,7 +14391,7 @@
                 </a:solidFill>
                 <a:latin typeface="Arial"/>
               </a:rPr>
-              <a:t>Tennessee 31 – Auburn 24</a:t>
+              <a:t>Ohio State 30 – Iowa 16</a:t>
             </a:r>
           </a:p>
         </p:txBody>
@@ -14446,7 +14446,7 @@
             <a:avLst/>
           </a:prstGeom>
           <a:solidFill>
-            <a:srgbClr val="0C2440"/>
+            <a:srgbClr val="BB0000"/>
           </a:solidFill>
           <a:ln>
             <a:noFill/>
@@ -14484,13 +14484,13 @@
         <p:spPr>
           <a:xfrm>
             <a:off x="8046720" y="4709160"/>
-            <a:ext cx="2021738" cy="365760"/>
+            <a:ext cx="573328" cy="365760"/>
           </a:xfrm>
           <a:prstGeom prst="roundRect">
             <a:avLst/>
           </a:prstGeom>
           <a:solidFill>
-            <a:srgbClr val="FF8200"/>
+            <a:srgbClr val="000000"/>
           </a:solidFill>
           <a:ln>
             <a:noFill/>
@@ -14545,11 +14545,11 @@
             <a:r>
               <a:rPr sz="1050" b="1" i="0">
                 <a:solidFill>
-                  <a:srgbClr val="16273D"/>
-                </a:solidFill>
-                <a:latin typeface="Arial"/>
-              </a:rPr>
-              <a:t>TENN 67%</a:t>
+                  <a:srgbClr val="FFFFFF"/>
+                </a:solidFill>
+                <a:latin typeface="Arial"/>
+              </a:rPr>
+              <a:t>IOWA 19%</a:t>
             </a:r>
           </a:p>
         </p:txBody>
@@ -14584,7 +14584,7 @@
                 </a:solidFill>
                 <a:latin typeface="Arial"/>
               </a:rPr>
-              <a:t>33% AUB</a:t>
+              <a:t>81% OSU</a:t>
             </a:r>
           </a:p>
         </p:txBody>
@@ -14652,7 +14652,7 @@
       <p:grpSpPr/>
       <p:pic>
         <p:nvPicPr>
-          <p:cNvPr id="2" name="Picture 1" descr="auburn.png"/>
+          <p:cNvPr id="2" name="Picture 1" descr="ohiostate.png"/>
           <p:cNvPicPr>
             <a:picLocks noChangeAspect="1"/>
           </p:cNvPicPr>
@@ -14704,7 +14704,7 @@
                 </a:solidFill>
                 <a:latin typeface="Arial"/>
               </a:rPr>
-              <a:t>Auburn</a:t>
+              <a:t>Ohio State</a:t>
             </a:r>
           </a:p>
         </p:txBody>
@@ -14739,7 +14739,7 @@
                 </a:solidFill>
                 <a:latin typeface="Arial"/>
               </a:rPr>
-              <a:t>What it takes to win · Auburn at Tennessee</a:t>
+              <a:t>What it takes to win · Ohio State at Iowa</a:t>
             </a:r>
           </a:p>
         </p:txBody>
@@ -14853,7 +14853,7 @@
                 </a:solidFill>
                 <a:latin typeface="Arial"/>
               </a:rPr>
-              <a:t>NEW — Alex Golesh</a:t>
+              <a:t>Day, year 8</a:t>
             </a:r>
           </a:p>
         </p:txBody>
@@ -14923,7 +14923,7 @@
                 </a:solidFill>
                 <a:latin typeface="Arial"/>
               </a:rPr>
-              <a:t>NEW — Byrum Brown (USF)</a:t>
+              <a:t>Sayin, year 2</a:t>
             </a:r>
           </a:p>
         </p:txBody>
@@ -14993,7 +14993,7 @@
                 </a:solidFill>
                 <a:latin typeface="Arial"/>
               </a:rPr>
-              <a:t>nine transfers on the line</a:t>
+              <a:t>three OL starters back</a:t>
             </a:r>
           </a:p>
         </p:txBody>
@@ -15072,7 +15072,7 @@
                 </a:solidFill>
                 <a:latin typeface="Arial"/>
               </a:rPr>
-              <a:t>Keep Brown upright</a:t>
+              <a:t>Sayin to Smith</a:t>
             </a:r>
           </a:p>
         </p:txBody>
@@ -15151,7 +15151,7 @@
                 </a:solidFill>
                 <a:latin typeface="Arial"/>
               </a:rPr>
-              <a:t>Run it</a:t>
+              <a:t>Run it at all</a:t>
             </a:r>
           </a:p>
         </p:txBody>
@@ -15230,7 +15230,7 @@
                 </a:solidFill>
                 <a:latin typeface="Arial"/>
               </a:rPr>
-              <a:t>Get Brandon on the ground</a:t>
+              <a:t>Third down and the red zone</a:t>
             </a:r>
           </a:p>
         </p:txBody>
@@ -15265,7 +15265,7 @@
                 </a:solidFill>
                 <a:latin typeface="Arial"/>
               </a:rPr>
-              <a:t>EP 6 · WEEK 5 · Auburn at Tennessee</a:t>
+              <a:t>EP 6 · WEEK 5 · Ohio State at Iowa</a:t>
             </a:r>
           </a:p>
         </p:txBody>
@@ -15298,7 +15298,7 @@
       <p:grpSpPr/>
       <p:pic>
         <p:nvPicPr>
-          <p:cNvPr id="2" name="Picture 1" descr="tennessee.png"/>
+          <p:cNvPr id="2" name="Picture 1" descr="iowa.png"/>
           <p:cNvPicPr>
             <a:picLocks noChangeAspect="1"/>
           </p:cNvPicPr>
@@ -15350,7 +15350,7 @@
                 </a:solidFill>
                 <a:latin typeface="Arial"/>
               </a:rPr>
-              <a:t>Tennessee</a:t>
+              <a:t>Iowa</a:t>
             </a:r>
           </a:p>
         </p:txBody>
@@ -15385,7 +15385,7 @@
                 </a:solidFill>
                 <a:latin typeface="Arial"/>
               </a:rPr>
-              <a:t>What it takes to win · Auburn at Tennessee</a:t>
+              <a:t>What it takes to win · Ohio State at Iowa</a:t>
             </a:r>
           </a:p>
         </p:txBody>
@@ -15499,7 +15499,7 @@
                 </a:solidFill>
                 <a:latin typeface="Arial"/>
               </a:rPr>
-              <a:t>Heupel, year 6</a:t>
+              <a:t>Ferentz, year 28</a:t>
             </a:r>
           </a:p>
         </p:txBody>
@@ -15569,7 +15569,7 @@
                 </a:solidFill>
                 <a:latin typeface="Arial"/>
               </a:rPr>
-              <a:t>Faizon Brandon, true freshman</a:t>
+              <a:t>Hank Brown won the derby</a:t>
             </a:r>
           </a:p>
         </p:txBody>
@@ -15639,7 +15639,7 @@
                 </a:solidFill>
                 <a:latin typeface="Arial"/>
               </a:rPr>
-              <a:t>35% back</a:t>
+              <a:t>last in the Big Ten in returning production</a:t>
             </a:r>
           </a:p>
         </p:txBody>
@@ -15718,7 +15718,7 @@
                 </a:solidFill>
                 <a:latin typeface="Arial"/>
               </a:rPr>
-              <a:t>Run it — the offense</a:t>
+              <a:t>Run the ball, run the clock</a:t>
             </a:r>
           </a:p>
         </p:txBody>
@@ -15797,7 +15797,7 @@
                 </a:solidFill>
                 <a:latin typeface="Arial"/>
               </a:rPr>
-              <a:t>Brandon's second real test</a:t>
+              <a:t>Brown has to hit something</a:t>
             </a:r>
           </a:p>
         </p:txBody>
@@ -15876,7 +15876,7 @@
                 </a:solidFill>
                 <a:latin typeface="Arial"/>
               </a:rPr>
-              <a:t>Protect him</a:t>
+              <a:t>Field position</a:t>
             </a:r>
           </a:p>
         </p:txBody>
@@ -15911,7 +15911,7 @@
                 </a:solidFill>
                 <a:latin typeface="Arial"/>
               </a:rPr>
-              <a:t>EP 6 · WEEK 5 · Auburn at Tennessee</a:t>
+              <a:t>EP 6 · WEEK 5 · Ohio State at Iowa</a:t>
             </a:r>
           </a:p>
         </p:txBody>
@@ -15944,7 +15944,7 @@
       <p:grpSpPr/>
       <p:pic>
         <p:nvPicPr>
-          <p:cNvPr id="2" name="Picture 1" descr="ohiostate.png"/>
+          <p:cNvPr id="2" name="Picture 1" descr="auburn.png"/>
           <p:cNvPicPr>
             <a:picLocks noChangeAspect="1"/>
           </p:cNvPicPr>
@@ -16003,7 +16003,7 @@
       </p:sp>
       <p:pic>
         <p:nvPicPr>
-          <p:cNvPr id="4" name="Picture 3" descr="iowa.png"/>
+          <p:cNvPr id="4" name="Picture 3" descr="tennessee.png"/>
           <p:cNvPicPr>
             <a:picLocks noChangeAspect="1"/>
           </p:cNvPicPr>
@@ -16055,7 +16055,7 @@
                 </a:solidFill>
                 <a:latin typeface="Arial"/>
               </a:rPr>
-              <a:t>Ohio State at Iowa</a:t>
+              <a:t>Auburn at Tennessee</a:t>
             </a:r>
           </a:p>
         </p:txBody>
@@ -16090,7 +16090,7 @@
                 </a:solidFill>
                 <a:latin typeface="Arial"/>
               </a:rPr>
-              <a:t>Sat Oct 3 · 3:30 ET · Iowa City · No. 5 at No. 14</a:t>
+              <a:t>Sat Oct 3 · 3:30 ET · Knoxville · Auburn at No. 17</a:t>
             </a:r>
           </a:p>
         </p:txBody>
@@ -16204,7 +16204,7 @@
                 </a:solidFill>
                 <a:latin typeface="Arial"/>
               </a:rPr>
-              <a:t>Best passing game vs a run-stuffing defense</a:t>
+              <a:t>Tennessee out-played Texas and lost</a:t>
             </a:r>
           </a:p>
         </p:txBody>
@@ -16283,7 +16283,7 @@
                 </a:solidFill>
                 <a:latin typeface="Arial"/>
               </a:rPr>
-              <a:t>81% — dead agreement with the market</a:t>
+              <a:t>67% — the machine and the market agree</a:t>
             </a:r>
           </a:p>
         </p:txBody>
@@ -16397,7 +16397,7 @@
                 </a:solidFill>
                 <a:latin typeface="Arial"/>
               </a:rPr>
-              <a:t>Ohio State –14</a:t>
+              <a:t>Tennessee –7</a:t>
             </a:r>
           </a:p>
         </p:txBody>
@@ -16432,7 +16432,7 @@
                 </a:solidFill>
                 <a:latin typeface="Arial"/>
               </a:rPr>
-              <a:t>Iowa +424 · Ohio State –424</a:t>
+              <a:t>Tennessee –205 · Auburn +205</a:t>
             </a:r>
           </a:p>
         </p:txBody>
@@ -16467,7 +16467,7 @@
                 </a:solidFill>
                 <a:latin typeface="Arial"/>
               </a:rPr>
-              <a:t>machine line · fair odds, no vig · raw margin Ohio State +14.1</a:t>
+              <a:t>machine line · fair odds, no vig · raw margin Tennessee +6.8</a:t>
             </a:r>
           </a:p>
         </p:txBody>
@@ -16502,7 +16502,7 @@
                 </a:solidFill>
                 <a:latin typeface="Arial"/>
               </a:rPr>
-              <a:t>Ohio State –14</a:t>
+              <a:t>Tennessee –7</a:t>
             </a:r>
           </a:p>
         </p:txBody>
@@ -16572,7 +16572,7 @@
                 </a:solidFill>
                 <a:latin typeface="Arial"/>
               </a:rPr>
-              <a:t>Ohio State 30 – Iowa 16</a:t>
+              <a:t>Tennessee 31 – Auburn 24</a:t>
             </a:r>
           </a:p>
         </p:txBody>
@@ -16627,7 +16627,7 @@
             <a:avLst/>
           </a:prstGeom>
           <a:solidFill>
-            <a:srgbClr val="BB0000"/>
+            <a:srgbClr val="0C2440"/>
           </a:solidFill>
           <a:ln>
             <a:noFill/>
@@ -16665,13 +16665,13 @@
         <p:spPr>
           <a:xfrm>
             <a:off x="8046720" y="4709160"/>
-            <a:ext cx="573328" cy="365760"/>
+            <a:ext cx="2021738" cy="365760"/>
           </a:xfrm>
           <a:prstGeom prst="roundRect">
             <a:avLst/>
           </a:prstGeom>
           <a:solidFill>
-            <a:srgbClr val="000000"/>
+            <a:srgbClr val="FF8200"/>
           </a:solidFill>
           <a:ln>
             <a:noFill/>
@@ -16726,11 +16726,11 @@
             <a:r>
               <a:rPr sz="1050" b="1" i="0">
                 <a:solidFill>
-                  <a:srgbClr val="FFFFFF"/>
-                </a:solidFill>
-                <a:latin typeface="Arial"/>
-              </a:rPr>
-              <a:t>IOWA 19%</a:t>
+                  <a:srgbClr val="16273D"/>
+                </a:solidFill>
+                <a:latin typeface="Arial"/>
+              </a:rPr>
+              <a:t>TENN 67%</a:t>
             </a:r>
           </a:p>
         </p:txBody>
@@ -16765,7 +16765,7 @@
                 </a:solidFill>
                 <a:latin typeface="Arial"/>
               </a:rPr>
-              <a:t>81% OSU</a:t>
+              <a:t>33% AUB</a:t>
             </a:r>
           </a:p>
         </p:txBody>
@@ -16833,7 +16833,7 @@
       <p:grpSpPr/>
       <p:pic>
         <p:nvPicPr>
-          <p:cNvPr id="2" name="Picture 1" descr="ohiostate.png"/>
+          <p:cNvPr id="2" name="Picture 1" descr="auburn.png"/>
           <p:cNvPicPr>
             <a:picLocks noChangeAspect="1"/>
           </p:cNvPicPr>
@@ -16885,7 +16885,7 @@
                 </a:solidFill>
                 <a:latin typeface="Arial"/>
               </a:rPr>
-              <a:t>Ohio State</a:t>
+              <a:t>Auburn</a:t>
             </a:r>
           </a:p>
         </p:txBody>
@@ -16920,7 +16920,7 @@
                 </a:solidFill>
                 <a:latin typeface="Arial"/>
               </a:rPr>
-              <a:t>What it takes to win · Ohio State at Iowa</a:t>
+              <a:t>What it takes to win · Auburn at Tennessee</a:t>
             </a:r>
           </a:p>
         </p:txBody>
@@ -17034,7 +17034,7 @@
                 </a:solidFill>
                 <a:latin typeface="Arial"/>
               </a:rPr>
-              <a:t>Day, year 8</a:t>
+              <a:t>NEW — Alex Golesh</a:t>
             </a:r>
           </a:p>
         </p:txBody>
@@ -17104,7 +17104,7 @@
                 </a:solidFill>
                 <a:latin typeface="Arial"/>
               </a:rPr>
-              <a:t>Sayin, year 2</a:t>
+              <a:t>NEW — Byrum Brown (USF)</a:t>
             </a:r>
           </a:p>
         </p:txBody>
@@ -17174,7 +17174,7 @@
                 </a:solidFill>
                 <a:latin typeface="Arial"/>
               </a:rPr>
-              <a:t>three OL starters back</a:t>
+              <a:t>nine transfers on the line</a:t>
             </a:r>
           </a:p>
         </p:txBody>
@@ -17253,7 +17253,7 @@
                 </a:solidFill>
                 <a:latin typeface="Arial"/>
               </a:rPr>
-              <a:t>Sayin to Smith</a:t>
+              <a:t>Keep Brown upright</a:t>
             </a:r>
           </a:p>
         </p:txBody>
@@ -17332,7 +17332,7 @@
                 </a:solidFill>
                 <a:latin typeface="Arial"/>
               </a:rPr>
-              <a:t>Run it at all</a:t>
+              <a:t>Run it</a:t>
             </a:r>
           </a:p>
         </p:txBody>
@@ -17411,7 +17411,7 @@
                 </a:solidFill>
                 <a:latin typeface="Arial"/>
               </a:rPr>
-              <a:t>Third down and the red zone</a:t>
+              <a:t>Get Brandon on the ground</a:t>
             </a:r>
           </a:p>
         </p:txBody>
@@ -17446,7 +17446,7 @@
                 </a:solidFill>
                 <a:latin typeface="Arial"/>
               </a:rPr>
-              <a:t>EP 6 · WEEK 5 · Ohio State at Iowa</a:t>
+              <a:t>EP 6 · WEEK 5 · Auburn at Tennessee</a:t>
             </a:r>
           </a:p>
         </p:txBody>
@@ -22439,7 +22439,7 @@
       <p:grpSpPr/>
       <p:pic>
         <p:nvPicPr>
-          <p:cNvPr id="2" name="Picture 1" descr="iowa.png"/>
+          <p:cNvPr id="2" name="Picture 1" descr="tennessee.png"/>
           <p:cNvPicPr>
             <a:picLocks noChangeAspect="1"/>
           </p:cNvPicPr>
@@ -22491,7 +22491,7 @@
                 </a:solidFill>
                 <a:latin typeface="Arial"/>
               </a:rPr>
-              <a:t>Iowa</a:t>
+              <a:t>Tennessee</a:t>
             </a:r>
           </a:p>
         </p:txBody>
@@ -22526,7 +22526,7 @@
                 </a:solidFill>
                 <a:latin typeface="Arial"/>
               </a:rPr>
-              <a:t>What it takes to win · Ohio State at Iowa</a:t>
+              <a:t>What it takes to win · Auburn at Tennessee</a:t>
             </a:r>
           </a:p>
         </p:txBody>
@@ -22640,7 +22640,7 @@
                 </a:solidFill>
                 <a:latin typeface="Arial"/>
               </a:rPr>
-              <a:t>Ferentz, year 28</a:t>
+              <a:t>Heupel, year 6</a:t>
             </a:r>
           </a:p>
         </p:txBody>
@@ -22710,7 +22710,7 @@
                 </a:solidFill>
                 <a:latin typeface="Arial"/>
               </a:rPr>
-              <a:t>Hank Brown won the derby</a:t>
+              <a:t>Faizon Brandon, true freshman</a:t>
             </a:r>
           </a:p>
         </p:txBody>
@@ -22780,7 +22780,7 @@
                 </a:solidFill>
                 <a:latin typeface="Arial"/>
               </a:rPr>
-              <a:t>last in the Big Ten in returning production</a:t>
+              <a:t>35% back</a:t>
             </a:r>
           </a:p>
         </p:txBody>
@@ -22859,7 +22859,7 @@
                 </a:solidFill>
                 <a:latin typeface="Arial"/>
               </a:rPr>
-              <a:t>Run the ball, run the clock</a:t>
+              <a:t>Run it — the offense</a:t>
             </a:r>
           </a:p>
         </p:txBody>
@@ -22938,7 +22938,7 @@
                 </a:solidFill>
                 <a:latin typeface="Arial"/>
               </a:rPr>
-              <a:t>Brown has to hit something</a:t>
+              <a:t>Brandon's second real test</a:t>
             </a:r>
           </a:p>
         </p:txBody>
@@ -23017,7 +23017,7 @@
                 </a:solidFill>
                 <a:latin typeface="Arial"/>
               </a:rPr>
-              <a:t>Field position</a:t>
+              <a:t>Protect him</a:t>
             </a:r>
           </a:p>
         </p:txBody>
@@ -23052,7 +23052,7 @@
                 </a:solidFill>
                 <a:latin typeface="Arial"/>
               </a:rPr>
-              <a:t>EP 6 · WEEK 5 · Ohio State at Iowa</a:t>
+              <a:t>EP 6 · WEEK 5 · Auburn at Tennessee</a:t>
             </a:r>
           </a:p>
         </p:txBody>
@@ -24203,7 +24203,7 @@
       </p:sp>
       <p:pic>
         <p:nvPicPr>
-          <p:cNvPr id="33" name="Picture 32" descr="auburn.png"/>
+          <p:cNvPr id="33" name="Picture 32" descr="ohiostate.png"/>
           <p:cNvPicPr>
             <a:picLocks noChangeAspect="1"/>
           </p:cNvPicPr>
@@ -24271,7 +24271,7 @@
       </p:sp>
       <p:pic>
         <p:nvPicPr>
-          <p:cNvPr id="35" name="Picture 34" descr="tennessee.png"/>
+          <p:cNvPr id="35" name="Picture 34" descr="iowa.png"/>
           <p:cNvPicPr>
             <a:picLocks noChangeAspect="1"/>
           </p:cNvPicPr>
@@ -24323,7 +24323,7 @@
                 </a:solidFill>
                 <a:latin typeface="Arial"/>
               </a:rPr>
-              <a:t>Auburn at Tennessee</a:t>
+              <a:t>Ohio State at Iowa</a:t>
             </a:r>
           </a:p>
         </p:txBody>
@@ -24358,7 +24358,7 @@
                 </a:solidFill>
                 <a:latin typeface="Arial"/>
               </a:rPr>
-              <a:t>Machine Tennessee 31 – Auburn 24</a:t>
+              <a:t>Machine Ohio State 30 – Iowa 16</a:t>
             </a:r>
           </a:p>
         </p:txBody>
@@ -24393,7 +24393,7 @@
                 </a:solidFill>
                 <a:latin typeface="Arial"/>
               </a:rPr>
-              <a:t>Man Tennessee 31–21</a:t>
+              <a:t>Man Ohio State 31–20</a:t>
             </a:r>
           </a:p>
         </p:txBody>
@@ -24428,7 +24428,7 @@
                 </a:solidFill>
                 <a:latin typeface="Arial"/>
               </a:rPr>
-              <a:t>machine Tennessee –7  ·  market Tennessee –7  ·  machine agrees</a:t>
+              <a:t>machine Ohio State –14  ·  market Ohio State –14  ·  machine agrees</a:t>
             </a:r>
           </a:p>
         </p:txBody>
@@ -24523,7 +24523,7 @@
       </p:sp>
       <p:pic>
         <p:nvPicPr>
-          <p:cNvPr id="42" name="Picture 41" descr="ohiostate.png"/>
+          <p:cNvPr id="42" name="Picture 41" descr="auburn.png"/>
           <p:cNvPicPr>
             <a:picLocks noChangeAspect="1"/>
           </p:cNvPicPr>
@@ -24591,7 +24591,7 @@
       </p:sp>
       <p:pic>
         <p:nvPicPr>
-          <p:cNvPr id="44" name="Picture 43" descr="iowa.png"/>
+          <p:cNvPr id="44" name="Picture 43" descr="tennessee.png"/>
           <p:cNvPicPr>
             <a:picLocks noChangeAspect="1"/>
           </p:cNvPicPr>
@@ -24643,7 +24643,7 @@
                 </a:solidFill>
                 <a:latin typeface="Arial"/>
               </a:rPr>
-              <a:t>Ohio State at Iowa</a:t>
+              <a:t>Auburn at Tennessee</a:t>
             </a:r>
           </a:p>
         </p:txBody>
@@ -24678,7 +24678,7 @@
                 </a:solidFill>
                 <a:latin typeface="Arial"/>
               </a:rPr>
-              <a:t>Machine Ohio State 30 – Iowa 16</a:t>
+              <a:t>Machine Tennessee 31 – Auburn 24</a:t>
             </a:r>
           </a:p>
         </p:txBody>
@@ -24713,7 +24713,7 @@
                 </a:solidFill>
                 <a:latin typeface="Arial"/>
               </a:rPr>
-              <a:t>Man Ohio State 31–20</a:t>
+              <a:t>Man Tennessee 31–21</a:t>
             </a:r>
           </a:p>
         </p:txBody>
@@ -24748,7 +24748,7 @@
                 </a:solidFill>
                 <a:latin typeface="Arial"/>
               </a:rPr>
-              <a:t>machine Ohio State –14  ·  market Ohio State –14  ·  machine agrees</a:t>
+              <a:t>machine Tennessee –7  ·  market Tennessee –7  ·  machine agrees</a:t>
             </a:r>
           </a:p>
         </p:txBody>
@@ -28550,7 +28550,7 @@
       </p:sp>
       <p:pic>
         <p:nvPicPr>
-          <p:cNvPr id="33" name="Picture 32" descr="auburn.png"/>
+          <p:cNvPr id="33" name="Picture 32" descr="ohiostate.png"/>
           <p:cNvPicPr>
             <a:picLocks noChangeAspect="1"/>
           </p:cNvPicPr>
@@ -28618,7 +28618,7 @@
       </p:sp>
       <p:pic>
         <p:nvPicPr>
-          <p:cNvPr id="35" name="Picture 34" descr="tennessee.png"/>
+          <p:cNvPr id="35" name="Picture 34" descr="iowa.png"/>
           <p:cNvPicPr>
             <a:picLocks noChangeAspect="1"/>
           </p:cNvPicPr>
@@ -28670,7 +28670,7 @@
                 </a:solidFill>
                 <a:latin typeface="Arial"/>
               </a:rPr>
-              <a:t>Auburn at Tennessee</a:t>
+              <a:t>Ohio State at Iowa</a:t>
             </a:r>
           </a:p>
         </p:txBody>
@@ -28705,7 +28705,7 @@
                 </a:solidFill>
                 <a:latin typeface="Arial"/>
               </a:rPr>
-              <a:t>Knoxville · Neyland Stadium</a:t>
+              <a:t>Iowa City · Kinnick Stadium</a:t>
             </a:r>
           </a:p>
         </p:txBody>
@@ -28870,7 +28870,7 @@
       </p:sp>
       <p:pic>
         <p:nvPicPr>
-          <p:cNvPr id="42" name="Picture 41" descr="ohiostate.png"/>
+          <p:cNvPr id="42" name="Picture 41" descr="auburn.png"/>
           <p:cNvPicPr>
             <a:picLocks noChangeAspect="1"/>
           </p:cNvPicPr>
@@ -28938,7 +28938,7 @@
       </p:sp>
       <p:pic>
         <p:nvPicPr>
-          <p:cNvPr id="44" name="Picture 43" descr="iowa.png"/>
+          <p:cNvPr id="44" name="Picture 43" descr="tennessee.png"/>
           <p:cNvPicPr>
             <a:picLocks noChangeAspect="1"/>
           </p:cNvPicPr>
@@ -28990,7 +28990,7 @@
                 </a:solidFill>
                 <a:latin typeface="Arial"/>
               </a:rPr>
-              <a:t>Ohio State at Iowa</a:t>
+              <a:t>Auburn at Tennessee</a:t>
             </a:r>
           </a:p>
         </p:txBody>
@@ -29025,7 +29025,7 @@
                 </a:solidFill>
                 <a:latin typeface="Arial"/>
               </a:rPr>
-              <a:t>Iowa City · Kinnick Stadium</a:t>
+              <a:t>Knoxville · Neyland Stadium</a:t>
             </a:r>
           </a:p>
         </p:txBody>

</xml_diff>

<commit_message>
Week 5 freeze: pre-mortems built (premortems.py --force --show now builds), deck on frozen card, notes carry the wrong-if lines
Co-Authored-By: Claude Fable 5.1 <noreply@anthropic.com>
</commit_message>
<xml_diff>
--- a/decks/2026_Week5_Episode6.pptx
+++ b/decks/2026_Week5_Episode6.pptx
@@ -11899,8 +11899,8 @@
         </p:nvSpPr>
         <p:spPr>
           <a:xfrm>
-            <a:off x="1051560" y="4983480"/>
-            <a:ext cx="6126480" cy="502920"/>
+            <a:off x="1051560" y="4846320"/>
+            <a:ext cx="6126480" cy="411480"/>
           </a:xfrm>
           <a:prstGeom prst="rect">
             <a:avLst/>
@@ -11915,7 +11915,7 @@
           <a:p>
             <a:pPr algn="l"/>
             <a:r>
-              <a:rPr sz="2000" b="1" i="0">
+              <a:rPr sz="1600" b="1" i="0">
                 <a:solidFill>
                   <a:srgbClr val="0A2851"/>
                 </a:solidFill>
@@ -11928,7 +11928,42 @@
       </p:sp>
       <p:sp>
         <p:nvSpPr>
-          <p:cNvPr id="12" name="Rounded Rectangle 11"/>
+          <p:cNvPr id="12" name="TextBox 11"/>
+          <p:cNvSpPr txBox="1"/>
+          <p:nvPr/>
+        </p:nvSpPr>
+        <p:spPr>
+          <a:xfrm>
+            <a:off x="1051560" y="5285232"/>
+            <a:ext cx="6126480" cy="365760"/>
+          </a:xfrm>
+          <a:prstGeom prst="rect">
+            <a:avLst/>
+          </a:prstGeom>
+          <a:noFill/>
+        </p:spPr>
+        <p:txBody>
+          <a:bodyPr wrap="square" lIns="0" rIns="0" tIns="0" bIns="0">
+            <a:spAutoFit/>
+          </a:bodyPr>
+          <a:lstStyle/>
+          <a:p>
+            <a:pPr algn="l"/>
+            <a:r>
+              <a:rPr sz="1250" b="1" i="0">
+                <a:solidFill>
+                  <a:srgbClr val="F47321"/>
+                </a:solidFill>
+                <a:latin typeface="Arial"/>
+              </a:rPr>
+              <a:t>Wrong if Mississippi State averages more than 4.2 yards a carry</a:t>
+            </a:r>
+          </a:p>
+        </p:txBody>
+      </p:sp>
+      <p:sp>
+        <p:nvSpPr>
+          <p:cNvPr id="13" name="Rounded Rectangle 12"/>
           <p:cNvSpPr/>
           <p:nvPr/>
         </p:nvSpPr>
@@ -11972,7 +12007,7 @@
       </p:sp>
       <p:sp>
         <p:nvSpPr>
-          <p:cNvPr id="13" name="TextBox 12"/>
+          <p:cNvPr id="14" name="TextBox 13"/>
           <p:cNvSpPr txBox="1"/>
           <p:nvPr/>
         </p:nvSpPr>
@@ -12007,7 +12042,7 @@
       </p:sp>
       <p:sp>
         <p:nvSpPr>
-          <p:cNvPr id="14" name="TextBox 13"/>
+          <p:cNvPr id="15" name="TextBox 14"/>
           <p:cNvSpPr txBox="1"/>
           <p:nvPr/>
         </p:nvSpPr>
@@ -12042,7 +12077,7 @@
       </p:sp>
       <p:sp>
         <p:nvSpPr>
-          <p:cNvPr id="15" name="TextBox 14"/>
+          <p:cNvPr id="16" name="TextBox 15"/>
           <p:cNvSpPr txBox="1"/>
           <p:nvPr/>
         </p:nvSpPr>
@@ -12077,7 +12112,7 @@
       </p:sp>
       <p:sp>
         <p:nvSpPr>
-          <p:cNvPr id="16" name="TextBox 15"/>
+          <p:cNvPr id="17" name="TextBox 16"/>
           <p:cNvSpPr txBox="1"/>
           <p:nvPr/>
         </p:nvSpPr>
@@ -12112,7 +12147,7 @@
       </p:sp>
       <p:sp>
         <p:nvSpPr>
-          <p:cNvPr id="17" name="TextBox 16"/>
+          <p:cNvPr id="18" name="TextBox 17"/>
           <p:cNvSpPr txBox="1"/>
           <p:nvPr/>
         </p:nvSpPr>
@@ -12147,7 +12182,7 @@
       </p:sp>
       <p:sp>
         <p:nvSpPr>
-          <p:cNvPr id="18" name="TextBox 17"/>
+          <p:cNvPr id="19" name="TextBox 18"/>
           <p:cNvSpPr txBox="1"/>
           <p:nvPr/>
         </p:nvSpPr>
@@ -12182,7 +12217,7 @@
       </p:sp>
       <p:sp>
         <p:nvSpPr>
-          <p:cNvPr id="19" name="TextBox 18"/>
+          <p:cNvPr id="20" name="TextBox 19"/>
           <p:cNvSpPr txBox="1"/>
           <p:nvPr/>
         </p:nvSpPr>
@@ -12217,7 +12252,7 @@
       </p:sp>
       <p:sp>
         <p:nvSpPr>
-          <p:cNvPr id="20" name="TextBox 19"/>
+          <p:cNvPr id="21" name="TextBox 20"/>
           <p:cNvSpPr txBox="1"/>
           <p:nvPr/>
         </p:nvSpPr>
@@ -12252,7 +12287,7 @@
       </p:sp>
       <p:sp>
         <p:nvSpPr>
-          <p:cNvPr id="21" name="Rounded Rectangle 20"/>
+          <p:cNvPr id="22" name="Rounded Rectangle 21"/>
           <p:cNvSpPr/>
           <p:nvPr/>
         </p:nvSpPr>
@@ -12296,7 +12331,7 @@
       </p:sp>
       <p:sp>
         <p:nvSpPr>
-          <p:cNvPr id="22" name="Rounded Rectangle 21"/>
+          <p:cNvPr id="23" name="Rounded Rectangle 22"/>
           <p:cNvSpPr/>
           <p:nvPr/>
         </p:nvSpPr>
@@ -12340,7 +12375,7 @@
       </p:sp>
       <p:sp>
         <p:nvSpPr>
-          <p:cNvPr id="23" name="TextBox 22"/>
+          <p:cNvPr id="24" name="TextBox 23"/>
           <p:cNvSpPr txBox="1"/>
           <p:nvPr/>
         </p:nvSpPr>
@@ -12375,7 +12410,7 @@
       </p:sp>
       <p:sp>
         <p:nvSpPr>
-          <p:cNvPr id="24" name="TextBox 23"/>
+          <p:cNvPr id="25" name="TextBox 24"/>
           <p:cNvSpPr txBox="1"/>
           <p:nvPr/>
         </p:nvSpPr>
@@ -12410,7 +12445,7 @@
       </p:sp>
       <p:sp>
         <p:nvSpPr>
-          <p:cNvPr id="25" name="TextBox 24"/>
+          <p:cNvPr id="26" name="TextBox 25"/>
           <p:cNvSpPr txBox="1"/>
           <p:nvPr/>
         </p:nvSpPr>
@@ -14080,8 +14115,8 @@
         </p:nvSpPr>
         <p:spPr>
           <a:xfrm>
-            <a:off x="1051560" y="4983480"/>
-            <a:ext cx="6126480" cy="502920"/>
+            <a:off x="1051560" y="4846320"/>
+            <a:ext cx="6126480" cy="411480"/>
           </a:xfrm>
           <a:prstGeom prst="rect">
             <a:avLst/>
@@ -14096,7 +14131,7 @@
           <a:p>
             <a:pPr algn="l"/>
             <a:r>
-              <a:rPr sz="2000" b="1" i="0">
+              <a:rPr sz="1600" b="1" i="0">
                 <a:solidFill>
                   <a:srgbClr val="0A2851"/>
                 </a:solidFill>
@@ -14109,7 +14144,42 @@
       </p:sp>
       <p:sp>
         <p:nvSpPr>
-          <p:cNvPr id="12" name="Rounded Rectangle 11"/>
+          <p:cNvPr id="12" name="TextBox 11"/>
+          <p:cNvSpPr txBox="1"/>
+          <p:nvPr/>
+        </p:nvSpPr>
+        <p:spPr>
+          <a:xfrm>
+            <a:off x="1051560" y="5285232"/>
+            <a:ext cx="6126480" cy="365760"/>
+          </a:xfrm>
+          <a:prstGeom prst="rect">
+            <a:avLst/>
+          </a:prstGeom>
+          <a:noFill/>
+        </p:spPr>
+        <p:txBody>
+          <a:bodyPr wrap="square" lIns="0" rIns="0" tIns="0" bIns="0">
+            <a:spAutoFit/>
+          </a:bodyPr>
+          <a:lstStyle/>
+          <a:p>
+            <a:pPr algn="l"/>
+            <a:r>
+              <a:rPr sz="1250" b="1" i="0">
+                <a:solidFill>
+                  <a:srgbClr val="F47321"/>
+                </a:solidFill>
+                <a:latin typeface="Arial"/>
+              </a:rPr>
+              <a:t>Wrong if Ohio State averages under 9.1 yards an attempt</a:t>
+            </a:r>
+          </a:p>
+        </p:txBody>
+      </p:sp>
+      <p:sp>
+        <p:nvSpPr>
+          <p:cNvPr id="13" name="Rounded Rectangle 12"/>
           <p:cNvSpPr/>
           <p:nvPr/>
         </p:nvSpPr>
@@ -14153,7 +14223,7 @@
       </p:sp>
       <p:sp>
         <p:nvSpPr>
-          <p:cNvPr id="13" name="TextBox 12"/>
+          <p:cNvPr id="14" name="TextBox 13"/>
           <p:cNvSpPr txBox="1"/>
           <p:nvPr/>
         </p:nvSpPr>
@@ -14188,7 +14258,7 @@
       </p:sp>
       <p:sp>
         <p:nvSpPr>
-          <p:cNvPr id="14" name="TextBox 13"/>
+          <p:cNvPr id="15" name="TextBox 14"/>
           <p:cNvSpPr txBox="1"/>
           <p:nvPr/>
         </p:nvSpPr>
@@ -14223,7 +14293,7 @@
       </p:sp>
       <p:sp>
         <p:nvSpPr>
-          <p:cNvPr id="15" name="TextBox 14"/>
+          <p:cNvPr id="16" name="TextBox 15"/>
           <p:cNvSpPr txBox="1"/>
           <p:nvPr/>
         </p:nvSpPr>
@@ -14258,7 +14328,7 @@
       </p:sp>
       <p:sp>
         <p:nvSpPr>
-          <p:cNvPr id="16" name="TextBox 15"/>
+          <p:cNvPr id="17" name="TextBox 16"/>
           <p:cNvSpPr txBox="1"/>
           <p:nvPr/>
         </p:nvSpPr>
@@ -14293,7 +14363,7 @@
       </p:sp>
       <p:sp>
         <p:nvSpPr>
-          <p:cNvPr id="17" name="TextBox 16"/>
+          <p:cNvPr id="18" name="TextBox 17"/>
           <p:cNvSpPr txBox="1"/>
           <p:nvPr/>
         </p:nvSpPr>
@@ -14321,14 +14391,14 @@
                 </a:solidFill>
                 <a:latin typeface="Arial"/>
               </a:rPr>
-              <a:t>Ohio State –14</a:t>
-            </a:r>
-          </a:p>
-        </p:txBody>
-      </p:sp>
-      <p:sp>
-        <p:nvSpPr>
-          <p:cNvPr id="18" name="TextBox 17"/>
+              <a:t>Ohio State –14.5</a:t>
+            </a:r>
+          </a:p>
+        </p:txBody>
+      </p:sp>
+      <p:sp>
+        <p:nvSpPr>
+          <p:cNvPr id="19" name="TextBox 18"/>
           <p:cNvSpPr txBox="1"/>
           <p:nvPr/>
         </p:nvSpPr>
@@ -14363,7 +14433,7 @@
       </p:sp>
       <p:sp>
         <p:nvSpPr>
-          <p:cNvPr id="19" name="TextBox 18"/>
+          <p:cNvPr id="20" name="TextBox 19"/>
           <p:cNvSpPr txBox="1"/>
           <p:nvPr/>
         </p:nvSpPr>
@@ -14398,7 +14468,7 @@
       </p:sp>
       <p:sp>
         <p:nvSpPr>
-          <p:cNvPr id="20" name="TextBox 19"/>
+          <p:cNvPr id="21" name="TextBox 20"/>
           <p:cNvSpPr txBox="1"/>
           <p:nvPr/>
         </p:nvSpPr>
@@ -14433,7 +14503,7 @@
       </p:sp>
       <p:sp>
         <p:nvSpPr>
-          <p:cNvPr id="21" name="Rounded Rectangle 20"/>
+          <p:cNvPr id="22" name="Rounded Rectangle 21"/>
           <p:cNvSpPr/>
           <p:nvPr/>
         </p:nvSpPr>
@@ -14477,7 +14547,7 @@
       </p:sp>
       <p:sp>
         <p:nvSpPr>
-          <p:cNvPr id="22" name="Rounded Rectangle 21"/>
+          <p:cNvPr id="23" name="Rounded Rectangle 22"/>
           <p:cNvSpPr/>
           <p:nvPr/>
         </p:nvSpPr>
@@ -14521,7 +14591,7 @@
       </p:sp>
       <p:sp>
         <p:nvSpPr>
-          <p:cNvPr id="23" name="TextBox 22"/>
+          <p:cNvPr id="24" name="TextBox 23"/>
           <p:cNvSpPr txBox="1"/>
           <p:nvPr/>
         </p:nvSpPr>
@@ -14556,7 +14626,7 @@
       </p:sp>
       <p:sp>
         <p:nvSpPr>
-          <p:cNvPr id="24" name="TextBox 23"/>
+          <p:cNvPr id="25" name="TextBox 24"/>
           <p:cNvSpPr txBox="1"/>
           <p:nvPr/>
         </p:nvSpPr>
@@ -14591,7 +14661,7 @@
       </p:sp>
       <p:sp>
         <p:nvSpPr>
-          <p:cNvPr id="25" name="TextBox 24"/>
+          <p:cNvPr id="26" name="TextBox 25"/>
           <p:cNvSpPr txBox="1"/>
           <p:nvPr/>
         </p:nvSpPr>
@@ -16261,8 +16331,8 @@
         </p:nvSpPr>
         <p:spPr>
           <a:xfrm>
-            <a:off x="1051560" y="4983480"/>
-            <a:ext cx="6126480" cy="502920"/>
+            <a:off x="1051560" y="4846320"/>
+            <a:ext cx="6126480" cy="411480"/>
           </a:xfrm>
           <a:prstGeom prst="rect">
             <a:avLst/>
@@ -16277,7 +16347,7 @@
           <a:p>
             <a:pPr algn="l"/>
             <a:r>
-              <a:rPr sz="2000" b="1" i="0">
+              <a:rPr sz="1600" b="1" i="0">
                 <a:solidFill>
                   <a:srgbClr val="0A2851"/>
                 </a:solidFill>
@@ -16290,7 +16360,42 @@
       </p:sp>
       <p:sp>
         <p:nvSpPr>
-          <p:cNvPr id="12" name="Rounded Rectangle 11"/>
+          <p:cNvPr id="12" name="TextBox 11"/>
+          <p:cNvSpPr txBox="1"/>
+          <p:nvPr/>
+        </p:nvSpPr>
+        <p:spPr>
+          <a:xfrm>
+            <a:off x="1051560" y="5285232"/>
+            <a:ext cx="6126480" cy="365760"/>
+          </a:xfrm>
+          <a:prstGeom prst="rect">
+            <a:avLst/>
+          </a:prstGeom>
+          <a:noFill/>
+        </p:spPr>
+        <p:txBody>
+          <a:bodyPr wrap="square" lIns="0" rIns="0" tIns="0" bIns="0">
+            <a:spAutoFit/>
+          </a:bodyPr>
+          <a:lstStyle/>
+          <a:p>
+            <a:pPr algn="l"/>
+            <a:r>
+              <a:rPr sz="1250" b="1" i="0">
+                <a:solidFill>
+                  <a:srgbClr val="F47321"/>
+                </a:solidFill>
+                <a:latin typeface="Arial"/>
+              </a:rPr>
+              <a:t>Wrong if Tennessee averages under 4.0 yards a carry</a:t>
+            </a:r>
+          </a:p>
+        </p:txBody>
+      </p:sp>
+      <p:sp>
+        <p:nvSpPr>
+          <p:cNvPr id="13" name="Rounded Rectangle 12"/>
           <p:cNvSpPr/>
           <p:nvPr/>
         </p:nvSpPr>
@@ -16334,7 +16439,7 @@
       </p:sp>
       <p:sp>
         <p:nvSpPr>
-          <p:cNvPr id="13" name="TextBox 12"/>
+          <p:cNvPr id="14" name="TextBox 13"/>
           <p:cNvSpPr txBox="1"/>
           <p:nvPr/>
         </p:nvSpPr>
@@ -16369,7 +16474,7 @@
       </p:sp>
       <p:sp>
         <p:nvSpPr>
-          <p:cNvPr id="14" name="TextBox 13"/>
+          <p:cNvPr id="15" name="TextBox 14"/>
           <p:cNvSpPr txBox="1"/>
           <p:nvPr/>
         </p:nvSpPr>
@@ -16404,7 +16509,7 @@
       </p:sp>
       <p:sp>
         <p:nvSpPr>
-          <p:cNvPr id="15" name="TextBox 14"/>
+          <p:cNvPr id="16" name="TextBox 15"/>
           <p:cNvSpPr txBox="1"/>
           <p:nvPr/>
         </p:nvSpPr>
@@ -16439,7 +16544,7 @@
       </p:sp>
       <p:sp>
         <p:nvSpPr>
-          <p:cNvPr id="16" name="TextBox 15"/>
+          <p:cNvPr id="17" name="TextBox 16"/>
           <p:cNvSpPr txBox="1"/>
           <p:nvPr/>
         </p:nvSpPr>
@@ -16474,7 +16579,7 @@
       </p:sp>
       <p:sp>
         <p:nvSpPr>
-          <p:cNvPr id="17" name="TextBox 16"/>
+          <p:cNvPr id="18" name="TextBox 17"/>
           <p:cNvSpPr txBox="1"/>
           <p:nvPr/>
         </p:nvSpPr>
@@ -16509,7 +16614,7 @@
       </p:sp>
       <p:sp>
         <p:nvSpPr>
-          <p:cNvPr id="18" name="TextBox 17"/>
+          <p:cNvPr id="19" name="TextBox 18"/>
           <p:cNvSpPr txBox="1"/>
           <p:nvPr/>
         </p:nvSpPr>
@@ -16544,7 +16649,7 @@
       </p:sp>
       <p:sp>
         <p:nvSpPr>
-          <p:cNvPr id="19" name="TextBox 18"/>
+          <p:cNvPr id="20" name="TextBox 19"/>
           <p:cNvSpPr txBox="1"/>
           <p:nvPr/>
         </p:nvSpPr>
@@ -16579,7 +16684,7 @@
       </p:sp>
       <p:sp>
         <p:nvSpPr>
-          <p:cNvPr id="20" name="TextBox 19"/>
+          <p:cNvPr id="21" name="TextBox 20"/>
           <p:cNvSpPr txBox="1"/>
           <p:nvPr/>
         </p:nvSpPr>
@@ -16614,7 +16719,7 @@
       </p:sp>
       <p:sp>
         <p:nvSpPr>
-          <p:cNvPr id="21" name="Rounded Rectangle 20"/>
+          <p:cNvPr id="22" name="Rounded Rectangle 21"/>
           <p:cNvSpPr/>
           <p:nvPr/>
         </p:nvSpPr>
@@ -16658,7 +16763,7 @@
       </p:sp>
       <p:sp>
         <p:nvSpPr>
-          <p:cNvPr id="22" name="Rounded Rectangle 21"/>
+          <p:cNvPr id="23" name="Rounded Rectangle 22"/>
           <p:cNvSpPr/>
           <p:nvPr/>
         </p:nvSpPr>
@@ -16702,7 +16807,7 @@
       </p:sp>
       <p:sp>
         <p:nvSpPr>
-          <p:cNvPr id="23" name="TextBox 22"/>
+          <p:cNvPr id="24" name="TextBox 23"/>
           <p:cNvSpPr txBox="1"/>
           <p:nvPr/>
         </p:nvSpPr>
@@ -16737,7 +16842,7 @@
       </p:sp>
       <p:sp>
         <p:nvSpPr>
-          <p:cNvPr id="24" name="TextBox 23"/>
+          <p:cNvPr id="25" name="TextBox 24"/>
           <p:cNvSpPr txBox="1"/>
           <p:nvPr/>
         </p:nvSpPr>
@@ -16772,7 +16877,7 @@
       </p:sp>
       <p:sp>
         <p:nvSpPr>
-          <p:cNvPr id="25" name="TextBox 24"/>
+          <p:cNvPr id="26" name="TextBox 25"/>
           <p:cNvSpPr txBox="1"/>
           <p:nvPr/>
         </p:nvSpPr>
@@ -23468,7 +23573,7 @@
                 </a:solidFill>
                 <a:latin typeface="Arial"/>
               </a:rPr>
-              <a:t>machine Pittsburgh –0.5  ·  market Virginia Tech –3.5  ·  machine 4 higher on Pittsburgh</a:t>
+              <a:t>machine Pittsburgh –0.5  ·  market Virginia Tech –3  ·  machine 3.5 higher on Pittsburgh</a:t>
             </a:r>
           </a:p>
         </p:txBody>
@@ -24428,7 +24533,7 @@
                 </a:solidFill>
                 <a:latin typeface="Arial"/>
               </a:rPr>
-              <a:t>machine Ohio State –14  ·  market Ohio State –14  ·  machine agrees</a:t>
+              <a:t>machine Ohio State –14  ·  market Ohio State –14.5  ·  machine agrees</a:t>
             </a:r>
           </a:p>
         </p:txBody>
@@ -24967,7 +25072,7 @@
                 </a:solidFill>
                 <a:latin typeface="Arial"/>
               </a:rPr>
-              <a:t>Superdogs: 5 for a cover · 5 + the spread for a win · 1 for a push · research, not picks · market = DraftKings, Sep 29</a:t>
+              <a:t>Superdogs: 5 for a cover · 5 + the spread for a win · 1 for a push · research, not picks · market = DraftKings, Sep 30</a:t>
             </a:r>
           </a:p>
         </p:txBody>
@@ -30850,8 +30955,8 @@
         </p:nvSpPr>
         <p:spPr>
           <a:xfrm>
-            <a:off x="1051560" y="4983480"/>
-            <a:ext cx="6126480" cy="502920"/>
+            <a:off x="1051560" y="4846320"/>
+            <a:ext cx="6126480" cy="411480"/>
           </a:xfrm>
           <a:prstGeom prst="rect">
             <a:avLst/>
@@ -30866,7 +30971,7 @@
           <a:p>
             <a:pPr algn="l"/>
             <a:r>
-              <a:rPr sz="2000" b="1" i="0">
+              <a:rPr sz="1600" b="1" i="0">
                 <a:solidFill>
                   <a:srgbClr val="0A2851"/>
                 </a:solidFill>
@@ -30879,7 +30984,42 @@
       </p:sp>
       <p:sp>
         <p:nvSpPr>
-          <p:cNvPr id="12" name="Rounded Rectangle 11"/>
+          <p:cNvPr id="12" name="TextBox 11"/>
+          <p:cNvSpPr txBox="1"/>
+          <p:nvPr/>
+        </p:nvSpPr>
+        <p:spPr>
+          <a:xfrm>
+            <a:off x="1051560" y="5285232"/>
+            <a:ext cx="6126480" cy="365760"/>
+          </a:xfrm>
+          <a:prstGeom prst="rect">
+            <a:avLst/>
+          </a:prstGeom>
+          <a:noFill/>
+        </p:spPr>
+        <p:txBody>
+          <a:bodyPr wrap="square" lIns="0" rIns="0" tIns="0" bIns="0">
+            <a:spAutoFit/>
+          </a:bodyPr>
+          <a:lstStyle/>
+          <a:p>
+            <a:pPr algn="l"/>
+            <a:r>
+              <a:rPr sz="1250" b="1" i="0">
+                <a:solidFill>
+                  <a:srgbClr val="F47321"/>
+                </a:solidFill>
+                <a:latin typeface="Arial"/>
+              </a:rPr>
+              <a:t>Wrong if Virginia Tech averages more than 3.0 yards a carry</a:t>
+            </a:r>
+          </a:p>
+        </p:txBody>
+      </p:sp>
+      <p:sp>
+        <p:nvSpPr>
+          <p:cNvPr id="13" name="Rounded Rectangle 12"/>
           <p:cNvSpPr/>
           <p:nvPr/>
         </p:nvSpPr>
@@ -30923,7 +31063,7 @@
       </p:sp>
       <p:sp>
         <p:nvSpPr>
-          <p:cNvPr id="13" name="TextBox 12"/>
+          <p:cNvPr id="14" name="TextBox 13"/>
           <p:cNvSpPr txBox="1"/>
           <p:nvPr/>
         </p:nvSpPr>
@@ -30958,7 +31098,7 @@
       </p:sp>
       <p:sp>
         <p:nvSpPr>
-          <p:cNvPr id="14" name="TextBox 13"/>
+          <p:cNvPr id="15" name="TextBox 14"/>
           <p:cNvSpPr txBox="1"/>
           <p:nvPr/>
         </p:nvSpPr>
@@ -30993,7 +31133,7 @@
       </p:sp>
       <p:sp>
         <p:nvSpPr>
-          <p:cNvPr id="15" name="TextBox 14"/>
+          <p:cNvPr id="16" name="TextBox 15"/>
           <p:cNvSpPr txBox="1"/>
           <p:nvPr/>
         </p:nvSpPr>
@@ -31028,7 +31168,7 @@
       </p:sp>
       <p:sp>
         <p:nvSpPr>
-          <p:cNvPr id="16" name="TextBox 15"/>
+          <p:cNvPr id="17" name="TextBox 16"/>
           <p:cNvSpPr txBox="1"/>
           <p:nvPr/>
         </p:nvSpPr>
@@ -31063,7 +31203,7 @@
       </p:sp>
       <p:sp>
         <p:nvSpPr>
-          <p:cNvPr id="17" name="TextBox 16"/>
+          <p:cNvPr id="18" name="TextBox 17"/>
           <p:cNvSpPr txBox="1"/>
           <p:nvPr/>
         </p:nvSpPr>
@@ -31091,14 +31231,14 @@
                 </a:solidFill>
                 <a:latin typeface="Arial"/>
               </a:rPr>
-              <a:t>Virginia Tech –3.5</a:t>
-            </a:r>
-          </a:p>
-        </p:txBody>
-      </p:sp>
-      <p:sp>
-        <p:nvSpPr>
-          <p:cNvPr id="18" name="TextBox 17"/>
+              <a:t>Virginia Tech –3</a:t>
+            </a:r>
+          </a:p>
+        </p:txBody>
+      </p:sp>
+      <p:sp>
+        <p:nvSpPr>
+          <p:cNvPr id="19" name="TextBox 18"/>
           <p:cNvSpPr txBox="1"/>
           <p:nvPr/>
         </p:nvSpPr>
@@ -31133,7 +31273,7 @@
       </p:sp>
       <p:sp>
         <p:nvSpPr>
-          <p:cNvPr id="19" name="TextBox 18"/>
+          <p:cNvPr id="20" name="TextBox 19"/>
           <p:cNvSpPr txBox="1"/>
           <p:nvPr/>
         </p:nvSpPr>
@@ -31168,7 +31308,7 @@
       </p:sp>
       <p:sp>
         <p:nvSpPr>
-          <p:cNvPr id="20" name="TextBox 19"/>
+          <p:cNvPr id="21" name="TextBox 20"/>
           <p:cNvSpPr txBox="1"/>
           <p:nvPr/>
         </p:nvSpPr>
@@ -31203,7 +31343,7 @@
       </p:sp>
       <p:sp>
         <p:nvSpPr>
-          <p:cNvPr id="21" name="Rounded Rectangle 20"/>
+          <p:cNvPr id="22" name="Rounded Rectangle 21"/>
           <p:cNvSpPr/>
           <p:nvPr/>
         </p:nvSpPr>
@@ -31247,7 +31387,7 @@
       </p:sp>
       <p:sp>
         <p:nvSpPr>
-          <p:cNvPr id="22" name="Rounded Rectangle 21"/>
+          <p:cNvPr id="23" name="Rounded Rectangle 22"/>
           <p:cNvSpPr/>
           <p:nvPr/>
         </p:nvSpPr>
@@ -31291,7 +31431,7 @@
       </p:sp>
       <p:sp>
         <p:nvSpPr>
-          <p:cNvPr id="23" name="TextBox 22"/>
+          <p:cNvPr id="24" name="TextBox 23"/>
           <p:cNvSpPr txBox="1"/>
           <p:nvPr/>
         </p:nvSpPr>
@@ -31326,7 +31466,7 @@
       </p:sp>
       <p:sp>
         <p:nvSpPr>
-          <p:cNvPr id="24" name="TextBox 23"/>
+          <p:cNvPr id="25" name="TextBox 24"/>
           <p:cNvSpPr txBox="1"/>
           <p:nvPr/>
         </p:nvSpPr>
@@ -31361,7 +31501,7 @@
       </p:sp>
       <p:sp>
         <p:nvSpPr>
-          <p:cNvPr id="25" name="TextBox 24"/>
+          <p:cNvPr id="26" name="TextBox 25"/>
           <p:cNvSpPr txBox="1"/>
           <p:nvPr/>
         </p:nvSpPr>
@@ -33031,8 +33171,8 @@
         </p:nvSpPr>
         <p:spPr>
           <a:xfrm>
-            <a:off x="1051560" y="4983480"/>
-            <a:ext cx="6126480" cy="502920"/>
+            <a:off x="1051560" y="4846320"/>
+            <a:ext cx="6126480" cy="411480"/>
           </a:xfrm>
           <a:prstGeom prst="rect">
             <a:avLst/>
@@ -33047,7 +33187,7 @@
           <a:p>
             <a:pPr algn="l"/>
             <a:r>
-              <a:rPr sz="2000" b="1" i="0">
+              <a:rPr sz="1600" b="1" i="0">
                 <a:solidFill>
                   <a:srgbClr val="0A2851"/>
                 </a:solidFill>
@@ -33060,7 +33200,42 @@
       </p:sp>
       <p:sp>
         <p:nvSpPr>
-          <p:cNvPr id="12" name="Rounded Rectangle 11"/>
+          <p:cNvPr id="12" name="TextBox 11"/>
+          <p:cNvSpPr txBox="1"/>
+          <p:nvPr/>
+        </p:nvSpPr>
+        <p:spPr>
+          <a:xfrm>
+            <a:off x="1051560" y="5285232"/>
+            <a:ext cx="6126480" cy="365760"/>
+          </a:xfrm>
+          <a:prstGeom prst="rect">
+            <a:avLst/>
+          </a:prstGeom>
+          <a:noFill/>
+        </p:spPr>
+        <p:txBody>
+          <a:bodyPr wrap="square" lIns="0" rIns="0" tIns="0" bIns="0">
+            <a:spAutoFit/>
+          </a:bodyPr>
+          <a:lstStyle/>
+          <a:p>
+            <a:pPr algn="l"/>
+            <a:r>
+              <a:rPr sz="1250" b="1" i="0">
+                <a:solidFill>
+                  <a:srgbClr val="F47321"/>
+                </a:solidFill>
+                <a:latin typeface="Arial"/>
+              </a:rPr>
+              <a:t>Wrong if Northwestern averages more than 7.4 yards an attempt</a:t>
+            </a:r>
+          </a:p>
+        </p:txBody>
+      </p:sp>
+      <p:sp>
+        <p:nvSpPr>
+          <p:cNvPr id="13" name="Rounded Rectangle 12"/>
           <p:cNvSpPr/>
           <p:nvPr/>
         </p:nvSpPr>
@@ -33104,7 +33279,7 @@
       </p:sp>
       <p:sp>
         <p:nvSpPr>
-          <p:cNvPr id="13" name="TextBox 12"/>
+          <p:cNvPr id="14" name="TextBox 13"/>
           <p:cNvSpPr txBox="1"/>
           <p:nvPr/>
         </p:nvSpPr>
@@ -33139,7 +33314,7 @@
       </p:sp>
       <p:sp>
         <p:nvSpPr>
-          <p:cNvPr id="14" name="TextBox 13"/>
+          <p:cNvPr id="15" name="TextBox 14"/>
           <p:cNvSpPr txBox="1"/>
           <p:nvPr/>
         </p:nvSpPr>
@@ -33174,7 +33349,7 @@
       </p:sp>
       <p:sp>
         <p:nvSpPr>
-          <p:cNvPr id="15" name="TextBox 14"/>
+          <p:cNvPr id="16" name="TextBox 15"/>
           <p:cNvSpPr txBox="1"/>
           <p:nvPr/>
         </p:nvSpPr>
@@ -33209,7 +33384,7 @@
       </p:sp>
       <p:sp>
         <p:nvSpPr>
-          <p:cNvPr id="16" name="TextBox 15"/>
+          <p:cNvPr id="17" name="TextBox 16"/>
           <p:cNvSpPr txBox="1"/>
           <p:nvPr/>
         </p:nvSpPr>
@@ -33244,7 +33419,7 @@
       </p:sp>
       <p:sp>
         <p:nvSpPr>
-          <p:cNvPr id="17" name="TextBox 16"/>
+          <p:cNvPr id="18" name="TextBox 17"/>
           <p:cNvSpPr txBox="1"/>
           <p:nvPr/>
         </p:nvSpPr>
@@ -33279,7 +33454,7 @@
       </p:sp>
       <p:sp>
         <p:nvSpPr>
-          <p:cNvPr id="18" name="TextBox 17"/>
+          <p:cNvPr id="19" name="TextBox 18"/>
           <p:cNvSpPr txBox="1"/>
           <p:nvPr/>
         </p:nvSpPr>
@@ -33314,7 +33489,7 @@
       </p:sp>
       <p:sp>
         <p:nvSpPr>
-          <p:cNvPr id="19" name="TextBox 18"/>
+          <p:cNvPr id="20" name="TextBox 19"/>
           <p:cNvSpPr txBox="1"/>
           <p:nvPr/>
         </p:nvSpPr>
@@ -33349,7 +33524,7 @@
       </p:sp>
       <p:sp>
         <p:nvSpPr>
-          <p:cNvPr id="20" name="TextBox 19"/>
+          <p:cNvPr id="21" name="TextBox 20"/>
           <p:cNvSpPr txBox="1"/>
           <p:nvPr/>
         </p:nvSpPr>
@@ -33384,7 +33559,7 @@
       </p:sp>
       <p:sp>
         <p:nvSpPr>
-          <p:cNvPr id="21" name="Rounded Rectangle 20"/>
+          <p:cNvPr id="22" name="Rounded Rectangle 21"/>
           <p:cNvSpPr/>
           <p:nvPr/>
         </p:nvSpPr>
@@ -33428,7 +33603,7 @@
       </p:sp>
       <p:sp>
         <p:nvSpPr>
-          <p:cNvPr id="22" name="Rounded Rectangle 21"/>
+          <p:cNvPr id="23" name="Rounded Rectangle 22"/>
           <p:cNvSpPr/>
           <p:nvPr/>
         </p:nvSpPr>
@@ -33472,7 +33647,7 @@
       </p:sp>
       <p:sp>
         <p:nvSpPr>
-          <p:cNvPr id="23" name="TextBox 22"/>
+          <p:cNvPr id="24" name="TextBox 23"/>
           <p:cNvSpPr txBox="1"/>
           <p:nvPr/>
         </p:nvSpPr>
@@ -33507,7 +33682,7 @@
       </p:sp>
       <p:sp>
         <p:nvSpPr>
-          <p:cNvPr id="24" name="TextBox 23"/>
+          <p:cNvPr id="25" name="TextBox 24"/>
           <p:cNvSpPr txBox="1"/>
           <p:nvPr/>
         </p:nvSpPr>
@@ -33542,7 +33717,7 @@
       </p:sp>
       <p:sp>
         <p:nvSpPr>
-          <p:cNvPr id="25" name="TextBox 24"/>
+          <p:cNvPr id="26" name="TextBox 25"/>
           <p:cNvSpPr txBox="1"/>
           <p:nvPr/>
         </p:nvSpPr>

</xml_diff>